<commit_message>
Preparar entrega final y presentacion de defensa
</commit_message>
<xml_diff>
--- a/docs/video/demo-portales-interno-externo.pptx
+++ b/docs/video/demo-portales-interno-externo.pptx
@@ -139,7 +139,7 @@
           <p:cNvPr id="2" name="Título 1">
             <a:extLst>
               <a:ext uri="{FF2B5EF4-FFF2-40B4-BE49-F238E27FC236}">
-                <a16:creationId xmlns:a16="http://schemas.microsoft.com/office/drawing/2014/main" id="{99A6826E-3ED7-986D-614E-672467AA8D8A}"/>
+                <a16:creationId xmlns:a16="http://schemas.microsoft.com/office/drawing/2014/main" id="{A806C32B-95F8-0CB8-15AF-E52BACCA719E}"/>
               </a:ext>
             </a:extLst>
           </p:cNvPr>
@@ -176,7 +176,7 @@
           <p:cNvPr id="3" name="Subtítulo 2">
             <a:extLst>
               <a:ext uri="{FF2B5EF4-FFF2-40B4-BE49-F238E27FC236}">
-                <a16:creationId xmlns:a16="http://schemas.microsoft.com/office/drawing/2014/main" id="{02311087-577E-F690-EA2E-D65621E86F95}"/>
+                <a16:creationId xmlns:a16="http://schemas.microsoft.com/office/drawing/2014/main" id="{3F396097-7924-3998-1C36-567F026FB313}"/>
               </a:ext>
             </a:extLst>
           </p:cNvPr>
@@ -246,7 +246,7 @@
           <p:cNvPr id="4" name="Marcador de fecha 3">
             <a:extLst>
               <a:ext uri="{FF2B5EF4-FFF2-40B4-BE49-F238E27FC236}">
-                <a16:creationId xmlns:a16="http://schemas.microsoft.com/office/drawing/2014/main" id="{53909D75-31CF-5BE1-1E9A-1088A33CF2E6}"/>
+                <a16:creationId xmlns:a16="http://schemas.microsoft.com/office/drawing/2014/main" id="{DA86F0EA-E90A-19B4-6630-4C086F3FB3A4}"/>
               </a:ext>
             </a:extLst>
           </p:cNvPr>
@@ -262,9 +262,9 @@
           <a:bodyPr/>
           <a:lstStyle/>
           <a:p>
-            <a:fld id="{A2DFCF2F-AD49-4E39-AA7D-24C32A86171D}" type="datetimeFigureOut">
+            <a:fld id="{00E44E50-88F2-4BF5-98DE-3ABAC7B3EF02}" type="datetimeFigureOut">
               <a:rPr lang="es-ES" smtClean="0"/>
-              <a:t>30/03/2026</a:t>
+              <a:t>12/04/2026</a:t>
             </a:fld>
             <a:endParaRPr lang="es-ES"/>
           </a:p>
@@ -275,7 +275,7 @@
           <p:cNvPr id="5" name="Marcador de pie de página 4">
             <a:extLst>
               <a:ext uri="{FF2B5EF4-FFF2-40B4-BE49-F238E27FC236}">
-                <a16:creationId xmlns:a16="http://schemas.microsoft.com/office/drawing/2014/main" id="{06824A2F-3750-96E8-B489-B5F94AB7A975}"/>
+                <a16:creationId xmlns:a16="http://schemas.microsoft.com/office/drawing/2014/main" id="{754E3273-E80D-01EA-C783-0286B466628F}"/>
               </a:ext>
             </a:extLst>
           </p:cNvPr>
@@ -300,7 +300,7 @@
           <p:cNvPr id="6" name="Marcador de número de diapositiva 5">
             <a:extLst>
               <a:ext uri="{FF2B5EF4-FFF2-40B4-BE49-F238E27FC236}">
-                <a16:creationId xmlns:a16="http://schemas.microsoft.com/office/drawing/2014/main" id="{E2DEC68A-644D-6E75-E4A1-F21CF6DADA92}"/>
+                <a16:creationId xmlns:a16="http://schemas.microsoft.com/office/drawing/2014/main" id="{31CB7B88-35A4-6F91-A0F2-F06597379ABE}"/>
               </a:ext>
             </a:extLst>
           </p:cNvPr>
@@ -316,7 +316,7 @@
           <a:bodyPr/>
           <a:lstStyle/>
           <a:p>
-            <a:fld id="{7D6E2D48-4366-4BA6-A433-D9E19997F8FC}" type="slidenum">
+            <a:fld id="{0E49D604-3501-452D-8397-28F2772CD1EC}" type="slidenum">
               <a:rPr lang="es-ES" smtClean="0"/>
               <a:t>‹Nº›</a:t>
             </a:fld>
@@ -327,7 +327,7 @@
     </p:spTree>
     <p:extLst>
       <p:ext uri="{BB962C8B-B14F-4D97-AF65-F5344CB8AC3E}">
-        <p14:creationId xmlns:p14="http://schemas.microsoft.com/office/powerpoint/2010/main" val="3882168797"/>
+        <p14:creationId xmlns:p14="http://schemas.microsoft.com/office/powerpoint/2010/main" val="1288592995"/>
       </p:ext>
     </p:extLst>
   </p:cSld>
@@ -359,7 +359,7 @@
           <p:cNvPr id="2" name="Título 1">
             <a:extLst>
               <a:ext uri="{FF2B5EF4-FFF2-40B4-BE49-F238E27FC236}">
-                <a16:creationId xmlns:a16="http://schemas.microsoft.com/office/drawing/2014/main" id="{3B55829D-3113-523E-AE5A-102AAE716DE1}"/>
+                <a16:creationId xmlns:a16="http://schemas.microsoft.com/office/drawing/2014/main" id="{40E45A06-DE9E-7BE3-D76F-2A759EED97C0}"/>
               </a:ext>
             </a:extLst>
           </p:cNvPr>
@@ -387,7 +387,7 @@
           <p:cNvPr id="3" name="Marcador de texto vertical 2">
             <a:extLst>
               <a:ext uri="{FF2B5EF4-FFF2-40B4-BE49-F238E27FC236}">
-                <a16:creationId xmlns:a16="http://schemas.microsoft.com/office/drawing/2014/main" id="{088CBD82-2A40-505F-5234-D542C0176C58}"/>
+                <a16:creationId xmlns:a16="http://schemas.microsoft.com/office/drawing/2014/main" id="{D9505CBE-2B65-7720-71CB-45D7D3FB234C}"/>
               </a:ext>
             </a:extLst>
           </p:cNvPr>
@@ -444,7 +444,7 @@
           <p:cNvPr id="4" name="Marcador de fecha 3">
             <a:extLst>
               <a:ext uri="{FF2B5EF4-FFF2-40B4-BE49-F238E27FC236}">
-                <a16:creationId xmlns:a16="http://schemas.microsoft.com/office/drawing/2014/main" id="{3CCDF953-E14B-9508-F3A6-1889F26E99AD}"/>
+                <a16:creationId xmlns:a16="http://schemas.microsoft.com/office/drawing/2014/main" id="{5907858D-1E8A-45BF-FCB2-DB0E0627EC61}"/>
               </a:ext>
             </a:extLst>
           </p:cNvPr>
@@ -460,9 +460,9 @@
           <a:bodyPr/>
           <a:lstStyle/>
           <a:p>
-            <a:fld id="{A2DFCF2F-AD49-4E39-AA7D-24C32A86171D}" type="datetimeFigureOut">
+            <a:fld id="{00E44E50-88F2-4BF5-98DE-3ABAC7B3EF02}" type="datetimeFigureOut">
               <a:rPr lang="es-ES" smtClean="0"/>
-              <a:t>30/03/2026</a:t>
+              <a:t>12/04/2026</a:t>
             </a:fld>
             <a:endParaRPr lang="es-ES"/>
           </a:p>
@@ -473,7 +473,7 @@
           <p:cNvPr id="5" name="Marcador de pie de página 4">
             <a:extLst>
               <a:ext uri="{FF2B5EF4-FFF2-40B4-BE49-F238E27FC236}">
-                <a16:creationId xmlns:a16="http://schemas.microsoft.com/office/drawing/2014/main" id="{2B40ABD2-D970-A29A-8B4E-D7EF565D4548}"/>
+                <a16:creationId xmlns:a16="http://schemas.microsoft.com/office/drawing/2014/main" id="{AB5B0907-E490-07C5-8AB1-513DC994A726}"/>
               </a:ext>
             </a:extLst>
           </p:cNvPr>
@@ -498,7 +498,7 @@
           <p:cNvPr id="6" name="Marcador de número de diapositiva 5">
             <a:extLst>
               <a:ext uri="{FF2B5EF4-FFF2-40B4-BE49-F238E27FC236}">
-                <a16:creationId xmlns:a16="http://schemas.microsoft.com/office/drawing/2014/main" id="{A730609B-5C74-9B18-B69A-1726EA329BFD}"/>
+                <a16:creationId xmlns:a16="http://schemas.microsoft.com/office/drawing/2014/main" id="{DA44E794-ADAA-8058-EC00-39F60443F59B}"/>
               </a:ext>
             </a:extLst>
           </p:cNvPr>
@@ -514,7 +514,7 @@
           <a:bodyPr/>
           <a:lstStyle/>
           <a:p>
-            <a:fld id="{7D6E2D48-4366-4BA6-A433-D9E19997F8FC}" type="slidenum">
+            <a:fld id="{0E49D604-3501-452D-8397-28F2772CD1EC}" type="slidenum">
               <a:rPr lang="es-ES" smtClean="0"/>
               <a:t>‹Nº›</a:t>
             </a:fld>
@@ -525,7 +525,7 @@
     </p:spTree>
     <p:extLst>
       <p:ext uri="{BB962C8B-B14F-4D97-AF65-F5344CB8AC3E}">
-        <p14:creationId xmlns:p14="http://schemas.microsoft.com/office/powerpoint/2010/main" val="706035553"/>
+        <p14:creationId xmlns:p14="http://schemas.microsoft.com/office/powerpoint/2010/main" val="1179183584"/>
       </p:ext>
     </p:extLst>
   </p:cSld>
@@ -557,7 +557,7 @@
           <p:cNvPr id="2" name="Título vertical 1">
             <a:extLst>
               <a:ext uri="{FF2B5EF4-FFF2-40B4-BE49-F238E27FC236}">
-                <a16:creationId xmlns:a16="http://schemas.microsoft.com/office/drawing/2014/main" id="{CBA002C0-8242-35E6-0CAB-D793C66EA49F}"/>
+                <a16:creationId xmlns:a16="http://schemas.microsoft.com/office/drawing/2014/main" id="{A29E8D08-CBF6-0D40-7EC1-AA137D97350F}"/>
               </a:ext>
             </a:extLst>
           </p:cNvPr>
@@ -590,7 +590,7 @@
           <p:cNvPr id="3" name="Marcador de texto vertical 2">
             <a:extLst>
               <a:ext uri="{FF2B5EF4-FFF2-40B4-BE49-F238E27FC236}">
-                <a16:creationId xmlns:a16="http://schemas.microsoft.com/office/drawing/2014/main" id="{68F33CBE-248E-C64F-F6AE-E348FC2B23AF}"/>
+                <a16:creationId xmlns:a16="http://schemas.microsoft.com/office/drawing/2014/main" id="{07718291-4698-24AA-6202-163D8644CF41}"/>
               </a:ext>
             </a:extLst>
           </p:cNvPr>
@@ -652,7 +652,7 @@
           <p:cNvPr id="4" name="Marcador de fecha 3">
             <a:extLst>
               <a:ext uri="{FF2B5EF4-FFF2-40B4-BE49-F238E27FC236}">
-                <a16:creationId xmlns:a16="http://schemas.microsoft.com/office/drawing/2014/main" id="{2669D6F4-DDCA-D29A-15DB-3DB6DE2E8E77}"/>
+                <a16:creationId xmlns:a16="http://schemas.microsoft.com/office/drawing/2014/main" id="{2076FE63-257D-02CB-7BE7-C2E8117B2D89}"/>
               </a:ext>
             </a:extLst>
           </p:cNvPr>
@@ -668,9 +668,9 @@
           <a:bodyPr/>
           <a:lstStyle/>
           <a:p>
-            <a:fld id="{A2DFCF2F-AD49-4E39-AA7D-24C32A86171D}" type="datetimeFigureOut">
+            <a:fld id="{00E44E50-88F2-4BF5-98DE-3ABAC7B3EF02}" type="datetimeFigureOut">
               <a:rPr lang="es-ES" smtClean="0"/>
-              <a:t>30/03/2026</a:t>
+              <a:t>12/04/2026</a:t>
             </a:fld>
             <a:endParaRPr lang="es-ES"/>
           </a:p>
@@ -681,7 +681,7 @@
           <p:cNvPr id="5" name="Marcador de pie de página 4">
             <a:extLst>
               <a:ext uri="{FF2B5EF4-FFF2-40B4-BE49-F238E27FC236}">
-                <a16:creationId xmlns:a16="http://schemas.microsoft.com/office/drawing/2014/main" id="{6B42E29F-7BE9-0904-6CC7-6804DAFD4E4A}"/>
+                <a16:creationId xmlns:a16="http://schemas.microsoft.com/office/drawing/2014/main" id="{29DC3843-AD78-ADE3-5BFC-33289966AC46}"/>
               </a:ext>
             </a:extLst>
           </p:cNvPr>
@@ -706,7 +706,7 @@
           <p:cNvPr id="6" name="Marcador de número de diapositiva 5">
             <a:extLst>
               <a:ext uri="{FF2B5EF4-FFF2-40B4-BE49-F238E27FC236}">
-                <a16:creationId xmlns:a16="http://schemas.microsoft.com/office/drawing/2014/main" id="{2F670D47-AB48-6B72-8055-E3B7FD54945F}"/>
+                <a16:creationId xmlns:a16="http://schemas.microsoft.com/office/drawing/2014/main" id="{BC5FE950-C2A4-E869-94E0-5ECEA5AD0800}"/>
               </a:ext>
             </a:extLst>
           </p:cNvPr>
@@ -722,7 +722,7 @@
           <a:bodyPr/>
           <a:lstStyle/>
           <a:p>
-            <a:fld id="{7D6E2D48-4366-4BA6-A433-D9E19997F8FC}" type="slidenum">
+            <a:fld id="{0E49D604-3501-452D-8397-28F2772CD1EC}" type="slidenum">
               <a:rPr lang="es-ES" smtClean="0"/>
               <a:t>‹Nº›</a:t>
             </a:fld>
@@ -733,7 +733,7 @@
     </p:spTree>
     <p:extLst>
       <p:ext uri="{BB962C8B-B14F-4D97-AF65-F5344CB8AC3E}">
-        <p14:creationId xmlns:p14="http://schemas.microsoft.com/office/powerpoint/2010/main" val="4257191821"/>
+        <p14:creationId xmlns:p14="http://schemas.microsoft.com/office/powerpoint/2010/main" val="1424245724"/>
       </p:ext>
     </p:extLst>
   </p:cSld>
@@ -765,7 +765,7 @@
           <p:cNvPr id="2" name="Título 1">
             <a:extLst>
               <a:ext uri="{FF2B5EF4-FFF2-40B4-BE49-F238E27FC236}">
-                <a16:creationId xmlns:a16="http://schemas.microsoft.com/office/drawing/2014/main" id="{2DF6E247-817D-937A-7203-D6682F5D1885}"/>
+                <a16:creationId xmlns:a16="http://schemas.microsoft.com/office/drawing/2014/main" id="{DAC281B3-B8C5-08D5-E625-8D7846C12A41}"/>
               </a:ext>
             </a:extLst>
           </p:cNvPr>
@@ -793,7 +793,7 @@
           <p:cNvPr id="3" name="Marcador de contenido 2">
             <a:extLst>
               <a:ext uri="{FF2B5EF4-FFF2-40B4-BE49-F238E27FC236}">
-                <a16:creationId xmlns:a16="http://schemas.microsoft.com/office/drawing/2014/main" id="{90655631-63B8-6432-7B19-7BFB36D6718D}"/>
+                <a16:creationId xmlns:a16="http://schemas.microsoft.com/office/drawing/2014/main" id="{A36BB646-1475-DAFE-A9BC-2C2FBB89B488}"/>
               </a:ext>
             </a:extLst>
           </p:cNvPr>
@@ -850,7 +850,7 @@
           <p:cNvPr id="4" name="Marcador de fecha 3">
             <a:extLst>
               <a:ext uri="{FF2B5EF4-FFF2-40B4-BE49-F238E27FC236}">
-                <a16:creationId xmlns:a16="http://schemas.microsoft.com/office/drawing/2014/main" id="{F1B80934-F5B6-16B2-0B8A-79402BC7B305}"/>
+                <a16:creationId xmlns:a16="http://schemas.microsoft.com/office/drawing/2014/main" id="{880AB18C-3B4A-8EAF-6859-D332F6166BB5}"/>
               </a:ext>
             </a:extLst>
           </p:cNvPr>
@@ -866,9 +866,9 @@
           <a:bodyPr/>
           <a:lstStyle/>
           <a:p>
-            <a:fld id="{A2DFCF2F-AD49-4E39-AA7D-24C32A86171D}" type="datetimeFigureOut">
+            <a:fld id="{00E44E50-88F2-4BF5-98DE-3ABAC7B3EF02}" type="datetimeFigureOut">
               <a:rPr lang="es-ES" smtClean="0"/>
-              <a:t>30/03/2026</a:t>
+              <a:t>12/04/2026</a:t>
             </a:fld>
             <a:endParaRPr lang="es-ES"/>
           </a:p>
@@ -879,7 +879,7 @@
           <p:cNvPr id="5" name="Marcador de pie de página 4">
             <a:extLst>
               <a:ext uri="{FF2B5EF4-FFF2-40B4-BE49-F238E27FC236}">
-                <a16:creationId xmlns:a16="http://schemas.microsoft.com/office/drawing/2014/main" id="{1D9C7CA4-B6FB-A020-15CB-0A49685B2CD6}"/>
+                <a16:creationId xmlns:a16="http://schemas.microsoft.com/office/drawing/2014/main" id="{A5788EEB-ED4C-CCA8-7539-9E3EC21AC2C8}"/>
               </a:ext>
             </a:extLst>
           </p:cNvPr>
@@ -904,7 +904,7 @@
           <p:cNvPr id="6" name="Marcador de número de diapositiva 5">
             <a:extLst>
               <a:ext uri="{FF2B5EF4-FFF2-40B4-BE49-F238E27FC236}">
-                <a16:creationId xmlns:a16="http://schemas.microsoft.com/office/drawing/2014/main" id="{130A4BD1-7F9B-D09A-B18B-95BD60988A68}"/>
+                <a16:creationId xmlns:a16="http://schemas.microsoft.com/office/drawing/2014/main" id="{95A168FB-D743-7D0A-37EA-E72D2A011614}"/>
               </a:ext>
             </a:extLst>
           </p:cNvPr>
@@ -920,7 +920,7 @@
           <a:bodyPr/>
           <a:lstStyle/>
           <a:p>
-            <a:fld id="{7D6E2D48-4366-4BA6-A433-D9E19997F8FC}" type="slidenum">
+            <a:fld id="{0E49D604-3501-452D-8397-28F2772CD1EC}" type="slidenum">
               <a:rPr lang="es-ES" smtClean="0"/>
               <a:t>‹Nº›</a:t>
             </a:fld>
@@ -931,7 +931,7 @@
     </p:spTree>
     <p:extLst>
       <p:ext uri="{BB962C8B-B14F-4D97-AF65-F5344CB8AC3E}">
-        <p14:creationId xmlns:p14="http://schemas.microsoft.com/office/powerpoint/2010/main" val="904138930"/>
+        <p14:creationId xmlns:p14="http://schemas.microsoft.com/office/powerpoint/2010/main" val="1646476910"/>
       </p:ext>
     </p:extLst>
   </p:cSld>
@@ -963,7 +963,7 @@
           <p:cNvPr id="2" name="Título 1">
             <a:extLst>
               <a:ext uri="{FF2B5EF4-FFF2-40B4-BE49-F238E27FC236}">
-                <a16:creationId xmlns:a16="http://schemas.microsoft.com/office/drawing/2014/main" id="{9236AC93-6B35-EFC2-79E7-450F19E7017B}"/>
+                <a16:creationId xmlns:a16="http://schemas.microsoft.com/office/drawing/2014/main" id="{FBAE8A09-402E-04F7-DC03-973FBAB088CF}"/>
               </a:ext>
             </a:extLst>
           </p:cNvPr>
@@ -1000,7 +1000,7 @@
           <p:cNvPr id="3" name="Marcador de texto 2">
             <a:extLst>
               <a:ext uri="{FF2B5EF4-FFF2-40B4-BE49-F238E27FC236}">
-                <a16:creationId xmlns:a16="http://schemas.microsoft.com/office/drawing/2014/main" id="{374B4416-91CA-CD74-E5A9-8E3468B947E2}"/>
+                <a16:creationId xmlns:a16="http://schemas.microsoft.com/office/drawing/2014/main" id="{189D0E08-569A-FDA2-925F-B11AE1E7DCB7}"/>
               </a:ext>
             </a:extLst>
           </p:cNvPr>
@@ -1125,7 +1125,7 @@
           <p:cNvPr id="4" name="Marcador de fecha 3">
             <a:extLst>
               <a:ext uri="{FF2B5EF4-FFF2-40B4-BE49-F238E27FC236}">
-                <a16:creationId xmlns:a16="http://schemas.microsoft.com/office/drawing/2014/main" id="{1D29B796-9877-43A3-C730-9D2FD7B5CCAB}"/>
+                <a16:creationId xmlns:a16="http://schemas.microsoft.com/office/drawing/2014/main" id="{9A5301EA-E641-AF20-A2C6-0EDE8B978423}"/>
               </a:ext>
             </a:extLst>
           </p:cNvPr>
@@ -1141,9 +1141,9 @@
           <a:bodyPr/>
           <a:lstStyle/>
           <a:p>
-            <a:fld id="{A2DFCF2F-AD49-4E39-AA7D-24C32A86171D}" type="datetimeFigureOut">
+            <a:fld id="{00E44E50-88F2-4BF5-98DE-3ABAC7B3EF02}" type="datetimeFigureOut">
               <a:rPr lang="es-ES" smtClean="0"/>
-              <a:t>30/03/2026</a:t>
+              <a:t>12/04/2026</a:t>
             </a:fld>
             <a:endParaRPr lang="es-ES"/>
           </a:p>
@@ -1154,7 +1154,7 @@
           <p:cNvPr id="5" name="Marcador de pie de página 4">
             <a:extLst>
               <a:ext uri="{FF2B5EF4-FFF2-40B4-BE49-F238E27FC236}">
-                <a16:creationId xmlns:a16="http://schemas.microsoft.com/office/drawing/2014/main" id="{6B52CE3E-0B19-4FDA-7917-9D6F12FCEAF2}"/>
+                <a16:creationId xmlns:a16="http://schemas.microsoft.com/office/drawing/2014/main" id="{946671BF-7E6C-3AEC-8D6E-2F3094F8AC34}"/>
               </a:ext>
             </a:extLst>
           </p:cNvPr>
@@ -1179,7 +1179,7 @@
           <p:cNvPr id="6" name="Marcador de número de diapositiva 5">
             <a:extLst>
               <a:ext uri="{FF2B5EF4-FFF2-40B4-BE49-F238E27FC236}">
-                <a16:creationId xmlns:a16="http://schemas.microsoft.com/office/drawing/2014/main" id="{7A1098E7-0352-709E-FE3E-94EE78CC0954}"/>
+                <a16:creationId xmlns:a16="http://schemas.microsoft.com/office/drawing/2014/main" id="{7FE52E1D-E78E-02F6-27FE-1CE7B1C714EE}"/>
               </a:ext>
             </a:extLst>
           </p:cNvPr>
@@ -1195,7 +1195,7 @@
           <a:bodyPr/>
           <a:lstStyle/>
           <a:p>
-            <a:fld id="{7D6E2D48-4366-4BA6-A433-D9E19997F8FC}" type="slidenum">
+            <a:fld id="{0E49D604-3501-452D-8397-28F2772CD1EC}" type="slidenum">
               <a:rPr lang="es-ES" smtClean="0"/>
               <a:t>‹Nº›</a:t>
             </a:fld>
@@ -1206,7 +1206,7 @@
     </p:spTree>
     <p:extLst>
       <p:ext uri="{BB962C8B-B14F-4D97-AF65-F5344CB8AC3E}">
-        <p14:creationId xmlns:p14="http://schemas.microsoft.com/office/powerpoint/2010/main" val="4058941122"/>
+        <p14:creationId xmlns:p14="http://schemas.microsoft.com/office/powerpoint/2010/main" val="1950761418"/>
       </p:ext>
     </p:extLst>
   </p:cSld>
@@ -1238,7 +1238,7 @@
           <p:cNvPr id="2" name="Título 1">
             <a:extLst>
               <a:ext uri="{FF2B5EF4-FFF2-40B4-BE49-F238E27FC236}">
-                <a16:creationId xmlns:a16="http://schemas.microsoft.com/office/drawing/2014/main" id="{FDD3A0DC-3FAA-0836-4A9B-D3647638D1F0}"/>
+                <a16:creationId xmlns:a16="http://schemas.microsoft.com/office/drawing/2014/main" id="{0219E97A-04ED-CC83-92FF-1ED81109446B}"/>
               </a:ext>
             </a:extLst>
           </p:cNvPr>
@@ -1266,7 +1266,7 @@
           <p:cNvPr id="3" name="Marcador de contenido 2">
             <a:extLst>
               <a:ext uri="{FF2B5EF4-FFF2-40B4-BE49-F238E27FC236}">
-                <a16:creationId xmlns:a16="http://schemas.microsoft.com/office/drawing/2014/main" id="{C5C6F4E0-BE29-BCF6-B876-4A45E7614E3F}"/>
+                <a16:creationId xmlns:a16="http://schemas.microsoft.com/office/drawing/2014/main" id="{654828F6-5F20-8A31-FB9E-D1D2B34CF6D6}"/>
               </a:ext>
             </a:extLst>
           </p:cNvPr>
@@ -1328,7 +1328,7 @@
           <p:cNvPr id="4" name="Marcador de contenido 3">
             <a:extLst>
               <a:ext uri="{FF2B5EF4-FFF2-40B4-BE49-F238E27FC236}">
-                <a16:creationId xmlns:a16="http://schemas.microsoft.com/office/drawing/2014/main" id="{EE639051-071A-F03D-8487-99126931BD2F}"/>
+                <a16:creationId xmlns:a16="http://schemas.microsoft.com/office/drawing/2014/main" id="{A1A4499B-36AE-5B6C-A669-2DD6FFC0442E}"/>
               </a:ext>
             </a:extLst>
           </p:cNvPr>
@@ -1390,7 +1390,7 @@
           <p:cNvPr id="5" name="Marcador de fecha 4">
             <a:extLst>
               <a:ext uri="{FF2B5EF4-FFF2-40B4-BE49-F238E27FC236}">
-                <a16:creationId xmlns:a16="http://schemas.microsoft.com/office/drawing/2014/main" id="{9D779451-4352-AB88-2B15-0D7C02C6BCB2}"/>
+                <a16:creationId xmlns:a16="http://schemas.microsoft.com/office/drawing/2014/main" id="{AA6C43CB-90D9-A33D-EE6E-BE9E10EC4DC8}"/>
               </a:ext>
             </a:extLst>
           </p:cNvPr>
@@ -1406,9 +1406,9 @@
           <a:bodyPr/>
           <a:lstStyle/>
           <a:p>
-            <a:fld id="{A2DFCF2F-AD49-4E39-AA7D-24C32A86171D}" type="datetimeFigureOut">
+            <a:fld id="{00E44E50-88F2-4BF5-98DE-3ABAC7B3EF02}" type="datetimeFigureOut">
               <a:rPr lang="es-ES" smtClean="0"/>
-              <a:t>30/03/2026</a:t>
+              <a:t>12/04/2026</a:t>
             </a:fld>
             <a:endParaRPr lang="es-ES"/>
           </a:p>
@@ -1419,7 +1419,7 @@
           <p:cNvPr id="6" name="Marcador de pie de página 5">
             <a:extLst>
               <a:ext uri="{FF2B5EF4-FFF2-40B4-BE49-F238E27FC236}">
-                <a16:creationId xmlns:a16="http://schemas.microsoft.com/office/drawing/2014/main" id="{6576987B-74A5-5BBF-3FEA-909966253B98}"/>
+                <a16:creationId xmlns:a16="http://schemas.microsoft.com/office/drawing/2014/main" id="{A7F2001B-FD92-AA4F-A8D0-AB413899AA83}"/>
               </a:ext>
             </a:extLst>
           </p:cNvPr>
@@ -1444,7 +1444,7 @@
           <p:cNvPr id="7" name="Marcador de número de diapositiva 6">
             <a:extLst>
               <a:ext uri="{FF2B5EF4-FFF2-40B4-BE49-F238E27FC236}">
-                <a16:creationId xmlns:a16="http://schemas.microsoft.com/office/drawing/2014/main" id="{05258429-FC90-5219-4A6D-E645C6D6D37C}"/>
+                <a16:creationId xmlns:a16="http://schemas.microsoft.com/office/drawing/2014/main" id="{E76D7065-2A74-E0E8-28C8-407CA31F26FC}"/>
               </a:ext>
             </a:extLst>
           </p:cNvPr>
@@ -1460,7 +1460,7 @@
           <a:bodyPr/>
           <a:lstStyle/>
           <a:p>
-            <a:fld id="{7D6E2D48-4366-4BA6-A433-D9E19997F8FC}" type="slidenum">
+            <a:fld id="{0E49D604-3501-452D-8397-28F2772CD1EC}" type="slidenum">
               <a:rPr lang="es-ES" smtClean="0"/>
               <a:t>‹Nº›</a:t>
             </a:fld>
@@ -1471,7 +1471,7 @@
     </p:spTree>
     <p:extLst>
       <p:ext uri="{BB962C8B-B14F-4D97-AF65-F5344CB8AC3E}">
-        <p14:creationId xmlns:p14="http://schemas.microsoft.com/office/powerpoint/2010/main" val="4110028511"/>
+        <p14:creationId xmlns:p14="http://schemas.microsoft.com/office/powerpoint/2010/main" val="3353864296"/>
       </p:ext>
     </p:extLst>
   </p:cSld>
@@ -1503,7 +1503,7 @@
           <p:cNvPr id="2" name="Título 1">
             <a:extLst>
               <a:ext uri="{FF2B5EF4-FFF2-40B4-BE49-F238E27FC236}">
-                <a16:creationId xmlns:a16="http://schemas.microsoft.com/office/drawing/2014/main" id="{5A9F3D3D-9019-FBCC-179D-E50018129C32}"/>
+                <a16:creationId xmlns:a16="http://schemas.microsoft.com/office/drawing/2014/main" id="{3C37F479-F20E-4279-50B3-7E3E95746215}"/>
               </a:ext>
             </a:extLst>
           </p:cNvPr>
@@ -1536,7 +1536,7 @@
           <p:cNvPr id="3" name="Marcador de texto 2">
             <a:extLst>
               <a:ext uri="{FF2B5EF4-FFF2-40B4-BE49-F238E27FC236}">
-                <a16:creationId xmlns:a16="http://schemas.microsoft.com/office/drawing/2014/main" id="{942DC658-633C-9647-07CE-11E8EB923111}"/>
+                <a16:creationId xmlns:a16="http://schemas.microsoft.com/office/drawing/2014/main" id="{EDEE52E6-A81B-1DCA-7EB6-7E8714CE1545}"/>
               </a:ext>
             </a:extLst>
           </p:cNvPr>
@@ -1607,7 +1607,7 @@
           <p:cNvPr id="4" name="Marcador de contenido 3">
             <a:extLst>
               <a:ext uri="{FF2B5EF4-FFF2-40B4-BE49-F238E27FC236}">
-                <a16:creationId xmlns:a16="http://schemas.microsoft.com/office/drawing/2014/main" id="{875746CF-7551-1E76-92FB-72C738097DF0}"/>
+                <a16:creationId xmlns:a16="http://schemas.microsoft.com/office/drawing/2014/main" id="{67943580-4F65-38C4-6437-3FB53284120B}"/>
               </a:ext>
             </a:extLst>
           </p:cNvPr>
@@ -1669,7 +1669,7 @@
           <p:cNvPr id="5" name="Marcador de texto 4">
             <a:extLst>
               <a:ext uri="{FF2B5EF4-FFF2-40B4-BE49-F238E27FC236}">
-                <a16:creationId xmlns:a16="http://schemas.microsoft.com/office/drawing/2014/main" id="{8254EA7D-1527-553C-467D-652BED86701D}"/>
+                <a16:creationId xmlns:a16="http://schemas.microsoft.com/office/drawing/2014/main" id="{D91AAAA1-1F6E-D9EB-5C2E-A9E4642B2A1A}"/>
               </a:ext>
             </a:extLst>
           </p:cNvPr>
@@ -1740,7 +1740,7 @@
           <p:cNvPr id="6" name="Marcador de contenido 5">
             <a:extLst>
               <a:ext uri="{FF2B5EF4-FFF2-40B4-BE49-F238E27FC236}">
-                <a16:creationId xmlns:a16="http://schemas.microsoft.com/office/drawing/2014/main" id="{300E1387-A64B-DFDC-6915-7D7BCD2AE65A}"/>
+                <a16:creationId xmlns:a16="http://schemas.microsoft.com/office/drawing/2014/main" id="{E1EE87F9-588E-0BDB-2CE0-DE8297A07262}"/>
               </a:ext>
             </a:extLst>
           </p:cNvPr>
@@ -1802,7 +1802,7 @@
           <p:cNvPr id="7" name="Marcador de fecha 6">
             <a:extLst>
               <a:ext uri="{FF2B5EF4-FFF2-40B4-BE49-F238E27FC236}">
-                <a16:creationId xmlns:a16="http://schemas.microsoft.com/office/drawing/2014/main" id="{0BF033E0-2B4A-1D99-E536-BEB3FF3AB80A}"/>
+                <a16:creationId xmlns:a16="http://schemas.microsoft.com/office/drawing/2014/main" id="{189FA6E6-2848-2FD1-6B51-6A5E88C2C5B6}"/>
               </a:ext>
             </a:extLst>
           </p:cNvPr>
@@ -1818,9 +1818,9 @@
           <a:bodyPr/>
           <a:lstStyle/>
           <a:p>
-            <a:fld id="{A2DFCF2F-AD49-4E39-AA7D-24C32A86171D}" type="datetimeFigureOut">
+            <a:fld id="{00E44E50-88F2-4BF5-98DE-3ABAC7B3EF02}" type="datetimeFigureOut">
               <a:rPr lang="es-ES" smtClean="0"/>
-              <a:t>30/03/2026</a:t>
+              <a:t>12/04/2026</a:t>
             </a:fld>
             <a:endParaRPr lang="es-ES"/>
           </a:p>
@@ -1831,7 +1831,7 @@
           <p:cNvPr id="8" name="Marcador de pie de página 7">
             <a:extLst>
               <a:ext uri="{FF2B5EF4-FFF2-40B4-BE49-F238E27FC236}">
-                <a16:creationId xmlns:a16="http://schemas.microsoft.com/office/drawing/2014/main" id="{684DCCCC-1F83-E233-B2BC-533BCA119AF1}"/>
+                <a16:creationId xmlns:a16="http://schemas.microsoft.com/office/drawing/2014/main" id="{60BC1378-EDC3-55BB-F621-5BE3778A732E}"/>
               </a:ext>
             </a:extLst>
           </p:cNvPr>
@@ -1856,7 +1856,7 @@
           <p:cNvPr id="9" name="Marcador de número de diapositiva 8">
             <a:extLst>
               <a:ext uri="{FF2B5EF4-FFF2-40B4-BE49-F238E27FC236}">
-                <a16:creationId xmlns:a16="http://schemas.microsoft.com/office/drawing/2014/main" id="{C35AF51E-CEA2-7DE6-EFF5-B2A8815035D1}"/>
+                <a16:creationId xmlns:a16="http://schemas.microsoft.com/office/drawing/2014/main" id="{17499364-8140-AE45-6548-B0BDFD80F8B1}"/>
               </a:ext>
             </a:extLst>
           </p:cNvPr>
@@ -1872,7 +1872,7 @@
           <a:bodyPr/>
           <a:lstStyle/>
           <a:p>
-            <a:fld id="{7D6E2D48-4366-4BA6-A433-D9E19997F8FC}" type="slidenum">
+            <a:fld id="{0E49D604-3501-452D-8397-28F2772CD1EC}" type="slidenum">
               <a:rPr lang="es-ES" smtClean="0"/>
               <a:t>‹Nº›</a:t>
             </a:fld>
@@ -1883,7 +1883,7 @@
     </p:spTree>
     <p:extLst>
       <p:ext uri="{BB962C8B-B14F-4D97-AF65-F5344CB8AC3E}">
-        <p14:creationId xmlns:p14="http://schemas.microsoft.com/office/powerpoint/2010/main" val="2838341609"/>
+        <p14:creationId xmlns:p14="http://schemas.microsoft.com/office/powerpoint/2010/main" val="2574612554"/>
       </p:ext>
     </p:extLst>
   </p:cSld>
@@ -1915,7 +1915,7 @@
           <p:cNvPr id="2" name="Título 1">
             <a:extLst>
               <a:ext uri="{FF2B5EF4-FFF2-40B4-BE49-F238E27FC236}">
-                <a16:creationId xmlns:a16="http://schemas.microsoft.com/office/drawing/2014/main" id="{04585D45-6241-20C9-B674-6DCFA875504D}"/>
+                <a16:creationId xmlns:a16="http://schemas.microsoft.com/office/drawing/2014/main" id="{122428F1-4E3B-5C68-794B-0A3FA665B802}"/>
               </a:ext>
             </a:extLst>
           </p:cNvPr>
@@ -1943,7 +1943,7 @@
           <p:cNvPr id="3" name="Marcador de fecha 2">
             <a:extLst>
               <a:ext uri="{FF2B5EF4-FFF2-40B4-BE49-F238E27FC236}">
-                <a16:creationId xmlns:a16="http://schemas.microsoft.com/office/drawing/2014/main" id="{AF89ED99-2E91-C99F-6BC2-D7ADF252F492}"/>
+                <a16:creationId xmlns:a16="http://schemas.microsoft.com/office/drawing/2014/main" id="{72E665BB-E735-461F-FCB6-0B073149E517}"/>
               </a:ext>
             </a:extLst>
           </p:cNvPr>
@@ -1959,9 +1959,9 @@
           <a:bodyPr/>
           <a:lstStyle/>
           <a:p>
-            <a:fld id="{A2DFCF2F-AD49-4E39-AA7D-24C32A86171D}" type="datetimeFigureOut">
+            <a:fld id="{00E44E50-88F2-4BF5-98DE-3ABAC7B3EF02}" type="datetimeFigureOut">
               <a:rPr lang="es-ES" smtClean="0"/>
-              <a:t>30/03/2026</a:t>
+              <a:t>12/04/2026</a:t>
             </a:fld>
             <a:endParaRPr lang="es-ES"/>
           </a:p>
@@ -1972,7 +1972,7 @@
           <p:cNvPr id="4" name="Marcador de pie de página 3">
             <a:extLst>
               <a:ext uri="{FF2B5EF4-FFF2-40B4-BE49-F238E27FC236}">
-                <a16:creationId xmlns:a16="http://schemas.microsoft.com/office/drawing/2014/main" id="{0F1AC9F2-EBCB-7B36-4719-8D8BF6DC9129}"/>
+                <a16:creationId xmlns:a16="http://schemas.microsoft.com/office/drawing/2014/main" id="{BD2CD6D2-3DDA-ED2B-E4C7-1C69A8F86C08}"/>
               </a:ext>
             </a:extLst>
           </p:cNvPr>
@@ -1997,7 +1997,7 @@
           <p:cNvPr id="5" name="Marcador de número de diapositiva 4">
             <a:extLst>
               <a:ext uri="{FF2B5EF4-FFF2-40B4-BE49-F238E27FC236}">
-                <a16:creationId xmlns:a16="http://schemas.microsoft.com/office/drawing/2014/main" id="{15949EEB-342E-628F-86F3-78381DF1E7EF}"/>
+                <a16:creationId xmlns:a16="http://schemas.microsoft.com/office/drawing/2014/main" id="{A4D6C2BB-8C27-69E3-3CFE-E6390F6CFF2C}"/>
               </a:ext>
             </a:extLst>
           </p:cNvPr>
@@ -2013,7 +2013,7 @@
           <a:bodyPr/>
           <a:lstStyle/>
           <a:p>
-            <a:fld id="{7D6E2D48-4366-4BA6-A433-D9E19997F8FC}" type="slidenum">
+            <a:fld id="{0E49D604-3501-452D-8397-28F2772CD1EC}" type="slidenum">
               <a:rPr lang="es-ES" smtClean="0"/>
               <a:t>‹Nº›</a:t>
             </a:fld>
@@ -2024,7 +2024,7 @@
     </p:spTree>
     <p:extLst>
       <p:ext uri="{BB962C8B-B14F-4D97-AF65-F5344CB8AC3E}">
-        <p14:creationId xmlns:p14="http://schemas.microsoft.com/office/powerpoint/2010/main" val="54447684"/>
+        <p14:creationId xmlns:p14="http://schemas.microsoft.com/office/powerpoint/2010/main" val="4191471250"/>
       </p:ext>
     </p:extLst>
   </p:cSld>
@@ -2056,7 +2056,7 @@
           <p:cNvPr id="2" name="Marcador de fecha 1">
             <a:extLst>
               <a:ext uri="{FF2B5EF4-FFF2-40B4-BE49-F238E27FC236}">
-                <a16:creationId xmlns:a16="http://schemas.microsoft.com/office/drawing/2014/main" id="{BCF5B729-C061-232E-1F5D-89E32571D221}"/>
+                <a16:creationId xmlns:a16="http://schemas.microsoft.com/office/drawing/2014/main" id="{D3B048A9-BD99-2375-585A-D4C868184A60}"/>
               </a:ext>
             </a:extLst>
           </p:cNvPr>
@@ -2072,9 +2072,9 @@
           <a:bodyPr/>
           <a:lstStyle/>
           <a:p>
-            <a:fld id="{A2DFCF2F-AD49-4E39-AA7D-24C32A86171D}" type="datetimeFigureOut">
+            <a:fld id="{00E44E50-88F2-4BF5-98DE-3ABAC7B3EF02}" type="datetimeFigureOut">
               <a:rPr lang="es-ES" smtClean="0"/>
-              <a:t>30/03/2026</a:t>
+              <a:t>12/04/2026</a:t>
             </a:fld>
             <a:endParaRPr lang="es-ES"/>
           </a:p>
@@ -2085,7 +2085,7 @@
           <p:cNvPr id="3" name="Marcador de pie de página 2">
             <a:extLst>
               <a:ext uri="{FF2B5EF4-FFF2-40B4-BE49-F238E27FC236}">
-                <a16:creationId xmlns:a16="http://schemas.microsoft.com/office/drawing/2014/main" id="{7FBDCBE6-4A7E-BC3A-B541-D85E30812FD6}"/>
+                <a16:creationId xmlns:a16="http://schemas.microsoft.com/office/drawing/2014/main" id="{BF3BEE9F-4604-5758-532F-44EEAF474DEA}"/>
               </a:ext>
             </a:extLst>
           </p:cNvPr>
@@ -2110,7 +2110,7 @@
           <p:cNvPr id="4" name="Marcador de número de diapositiva 3">
             <a:extLst>
               <a:ext uri="{FF2B5EF4-FFF2-40B4-BE49-F238E27FC236}">
-                <a16:creationId xmlns:a16="http://schemas.microsoft.com/office/drawing/2014/main" id="{A536CF4C-EE4E-1C6F-C09B-284B4EEC6F0F}"/>
+                <a16:creationId xmlns:a16="http://schemas.microsoft.com/office/drawing/2014/main" id="{FA4D87F5-D29E-2EB1-89FB-BBF1D66A88BA}"/>
               </a:ext>
             </a:extLst>
           </p:cNvPr>
@@ -2126,7 +2126,7 @@
           <a:bodyPr/>
           <a:lstStyle/>
           <a:p>
-            <a:fld id="{7D6E2D48-4366-4BA6-A433-D9E19997F8FC}" type="slidenum">
+            <a:fld id="{0E49D604-3501-452D-8397-28F2772CD1EC}" type="slidenum">
               <a:rPr lang="es-ES" smtClean="0"/>
               <a:t>‹Nº›</a:t>
             </a:fld>
@@ -2137,7 +2137,7 @@
     </p:spTree>
     <p:extLst>
       <p:ext uri="{BB962C8B-B14F-4D97-AF65-F5344CB8AC3E}">
-        <p14:creationId xmlns:p14="http://schemas.microsoft.com/office/powerpoint/2010/main" val="237337316"/>
+        <p14:creationId xmlns:p14="http://schemas.microsoft.com/office/powerpoint/2010/main" val="908986423"/>
       </p:ext>
     </p:extLst>
   </p:cSld>
@@ -2169,7 +2169,7 @@
           <p:cNvPr id="2" name="Título 1">
             <a:extLst>
               <a:ext uri="{FF2B5EF4-FFF2-40B4-BE49-F238E27FC236}">
-                <a16:creationId xmlns:a16="http://schemas.microsoft.com/office/drawing/2014/main" id="{523FA076-DA6D-2B07-4FB0-7312572F8BD1}"/>
+                <a16:creationId xmlns:a16="http://schemas.microsoft.com/office/drawing/2014/main" id="{B5EEB268-9EB8-4435-ABC0-5ABA1610DC5B}"/>
               </a:ext>
             </a:extLst>
           </p:cNvPr>
@@ -2206,7 +2206,7 @@
           <p:cNvPr id="3" name="Marcador de contenido 2">
             <a:extLst>
               <a:ext uri="{FF2B5EF4-FFF2-40B4-BE49-F238E27FC236}">
-                <a16:creationId xmlns:a16="http://schemas.microsoft.com/office/drawing/2014/main" id="{E9E25064-599C-46ED-8493-B68049423366}"/>
+                <a16:creationId xmlns:a16="http://schemas.microsoft.com/office/drawing/2014/main" id="{435E207C-D956-A236-1D66-8F3EED6567C3}"/>
               </a:ext>
             </a:extLst>
           </p:cNvPr>
@@ -2296,7 +2296,7 @@
           <p:cNvPr id="4" name="Marcador de texto 3">
             <a:extLst>
               <a:ext uri="{FF2B5EF4-FFF2-40B4-BE49-F238E27FC236}">
-                <a16:creationId xmlns:a16="http://schemas.microsoft.com/office/drawing/2014/main" id="{9725B9A6-0F32-C219-13F7-BC277990D958}"/>
+                <a16:creationId xmlns:a16="http://schemas.microsoft.com/office/drawing/2014/main" id="{E0DE1F64-9FBF-0CC0-EF4E-40FD750A15A8}"/>
               </a:ext>
             </a:extLst>
           </p:cNvPr>
@@ -2367,7 +2367,7 @@
           <p:cNvPr id="5" name="Marcador de fecha 4">
             <a:extLst>
               <a:ext uri="{FF2B5EF4-FFF2-40B4-BE49-F238E27FC236}">
-                <a16:creationId xmlns:a16="http://schemas.microsoft.com/office/drawing/2014/main" id="{9E1A5F44-3D82-0DBC-B25E-840E1D8A9607}"/>
+                <a16:creationId xmlns:a16="http://schemas.microsoft.com/office/drawing/2014/main" id="{1F387059-F3A4-D2A1-6BAC-E444FC18B145}"/>
               </a:ext>
             </a:extLst>
           </p:cNvPr>
@@ -2383,9 +2383,9 @@
           <a:bodyPr/>
           <a:lstStyle/>
           <a:p>
-            <a:fld id="{A2DFCF2F-AD49-4E39-AA7D-24C32A86171D}" type="datetimeFigureOut">
+            <a:fld id="{00E44E50-88F2-4BF5-98DE-3ABAC7B3EF02}" type="datetimeFigureOut">
               <a:rPr lang="es-ES" smtClean="0"/>
-              <a:t>30/03/2026</a:t>
+              <a:t>12/04/2026</a:t>
             </a:fld>
             <a:endParaRPr lang="es-ES"/>
           </a:p>
@@ -2396,7 +2396,7 @@
           <p:cNvPr id="6" name="Marcador de pie de página 5">
             <a:extLst>
               <a:ext uri="{FF2B5EF4-FFF2-40B4-BE49-F238E27FC236}">
-                <a16:creationId xmlns:a16="http://schemas.microsoft.com/office/drawing/2014/main" id="{9AC918BD-0F54-2E48-211D-92FE14CE8115}"/>
+                <a16:creationId xmlns:a16="http://schemas.microsoft.com/office/drawing/2014/main" id="{6FD4BD51-ED0C-33C1-12ED-1A6F97EC804A}"/>
               </a:ext>
             </a:extLst>
           </p:cNvPr>
@@ -2421,7 +2421,7 @@
           <p:cNvPr id="7" name="Marcador de número de diapositiva 6">
             <a:extLst>
               <a:ext uri="{FF2B5EF4-FFF2-40B4-BE49-F238E27FC236}">
-                <a16:creationId xmlns:a16="http://schemas.microsoft.com/office/drawing/2014/main" id="{F5413214-9EEF-EB09-8398-C0E33AE9F3E7}"/>
+                <a16:creationId xmlns:a16="http://schemas.microsoft.com/office/drawing/2014/main" id="{3CB36470-FAAE-8813-CAE9-200892A99848}"/>
               </a:ext>
             </a:extLst>
           </p:cNvPr>
@@ -2437,7 +2437,7 @@
           <a:bodyPr/>
           <a:lstStyle/>
           <a:p>
-            <a:fld id="{7D6E2D48-4366-4BA6-A433-D9E19997F8FC}" type="slidenum">
+            <a:fld id="{0E49D604-3501-452D-8397-28F2772CD1EC}" type="slidenum">
               <a:rPr lang="es-ES" smtClean="0"/>
               <a:t>‹Nº›</a:t>
             </a:fld>
@@ -2448,7 +2448,7 @@
     </p:spTree>
     <p:extLst>
       <p:ext uri="{BB962C8B-B14F-4D97-AF65-F5344CB8AC3E}">
-        <p14:creationId xmlns:p14="http://schemas.microsoft.com/office/powerpoint/2010/main" val="4054329582"/>
+        <p14:creationId xmlns:p14="http://schemas.microsoft.com/office/powerpoint/2010/main" val="3334073659"/>
       </p:ext>
     </p:extLst>
   </p:cSld>
@@ -2480,7 +2480,7 @@
           <p:cNvPr id="2" name="Título 1">
             <a:extLst>
               <a:ext uri="{FF2B5EF4-FFF2-40B4-BE49-F238E27FC236}">
-                <a16:creationId xmlns:a16="http://schemas.microsoft.com/office/drawing/2014/main" id="{B3436C00-288D-A50E-481F-4C45861355D7}"/>
+                <a16:creationId xmlns:a16="http://schemas.microsoft.com/office/drawing/2014/main" id="{A52CA4D5-C841-D735-536B-4E9C8C872F66}"/>
               </a:ext>
             </a:extLst>
           </p:cNvPr>
@@ -2517,7 +2517,7 @@
           <p:cNvPr id="3" name="Marcador de posición de imagen 2">
             <a:extLst>
               <a:ext uri="{FF2B5EF4-FFF2-40B4-BE49-F238E27FC236}">
-                <a16:creationId xmlns:a16="http://schemas.microsoft.com/office/drawing/2014/main" id="{B26463CB-1639-D1B8-0F9B-5C012A736F74}"/>
+                <a16:creationId xmlns:a16="http://schemas.microsoft.com/office/drawing/2014/main" id="{80400607-52AB-8760-0C15-777F4D4D8940}"/>
               </a:ext>
             </a:extLst>
           </p:cNvPr>
@@ -2584,7 +2584,7 @@
           <p:cNvPr id="4" name="Marcador de texto 3">
             <a:extLst>
               <a:ext uri="{FF2B5EF4-FFF2-40B4-BE49-F238E27FC236}">
-                <a16:creationId xmlns:a16="http://schemas.microsoft.com/office/drawing/2014/main" id="{03BA2908-6A07-6A0B-4C64-55D34A56747A}"/>
+                <a16:creationId xmlns:a16="http://schemas.microsoft.com/office/drawing/2014/main" id="{16BA020B-F1CA-8CD0-B984-DF8ABF68D1F8}"/>
               </a:ext>
             </a:extLst>
           </p:cNvPr>
@@ -2655,7 +2655,7 @@
           <p:cNvPr id="5" name="Marcador de fecha 4">
             <a:extLst>
               <a:ext uri="{FF2B5EF4-FFF2-40B4-BE49-F238E27FC236}">
-                <a16:creationId xmlns:a16="http://schemas.microsoft.com/office/drawing/2014/main" id="{85B62728-D574-6126-40F2-2C159803DFD7}"/>
+                <a16:creationId xmlns:a16="http://schemas.microsoft.com/office/drawing/2014/main" id="{D3CCE050-CDF4-8778-78F5-37F513CB9B99}"/>
               </a:ext>
             </a:extLst>
           </p:cNvPr>
@@ -2671,9 +2671,9 @@
           <a:bodyPr/>
           <a:lstStyle/>
           <a:p>
-            <a:fld id="{A2DFCF2F-AD49-4E39-AA7D-24C32A86171D}" type="datetimeFigureOut">
+            <a:fld id="{00E44E50-88F2-4BF5-98DE-3ABAC7B3EF02}" type="datetimeFigureOut">
               <a:rPr lang="es-ES" smtClean="0"/>
-              <a:t>30/03/2026</a:t>
+              <a:t>12/04/2026</a:t>
             </a:fld>
             <a:endParaRPr lang="es-ES"/>
           </a:p>
@@ -2684,7 +2684,7 @@
           <p:cNvPr id="6" name="Marcador de pie de página 5">
             <a:extLst>
               <a:ext uri="{FF2B5EF4-FFF2-40B4-BE49-F238E27FC236}">
-                <a16:creationId xmlns:a16="http://schemas.microsoft.com/office/drawing/2014/main" id="{5D86F769-AC48-3A97-57A5-5A532BAEF9E7}"/>
+                <a16:creationId xmlns:a16="http://schemas.microsoft.com/office/drawing/2014/main" id="{1AA03A23-AF95-B7F3-F81E-0B991AC7C894}"/>
               </a:ext>
             </a:extLst>
           </p:cNvPr>
@@ -2709,7 +2709,7 @@
           <p:cNvPr id="7" name="Marcador de número de diapositiva 6">
             <a:extLst>
               <a:ext uri="{FF2B5EF4-FFF2-40B4-BE49-F238E27FC236}">
-                <a16:creationId xmlns:a16="http://schemas.microsoft.com/office/drawing/2014/main" id="{76C104B7-306A-E8B0-302E-F0EE6A48BB58}"/>
+                <a16:creationId xmlns:a16="http://schemas.microsoft.com/office/drawing/2014/main" id="{A47CCD64-4E65-B09A-D947-DF081219A433}"/>
               </a:ext>
             </a:extLst>
           </p:cNvPr>
@@ -2725,7 +2725,7 @@
           <a:bodyPr/>
           <a:lstStyle/>
           <a:p>
-            <a:fld id="{7D6E2D48-4366-4BA6-A433-D9E19997F8FC}" type="slidenum">
+            <a:fld id="{0E49D604-3501-452D-8397-28F2772CD1EC}" type="slidenum">
               <a:rPr lang="es-ES" smtClean="0"/>
               <a:t>‹Nº›</a:t>
             </a:fld>
@@ -2736,7 +2736,7 @@
     </p:spTree>
     <p:extLst>
       <p:ext uri="{BB962C8B-B14F-4D97-AF65-F5344CB8AC3E}">
-        <p14:creationId xmlns:p14="http://schemas.microsoft.com/office/powerpoint/2010/main" val="145861341"/>
+        <p14:creationId xmlns:p14="http://schemas.microsoft.com/office/powerpoint/2010/main" val="3880734583"/>
       </p:ext>
     </p:extLst>
   </p:cSld>
@@ -2773,7 +2773,7 @@
           <p:cNvPr id="2" name="Marcador de título 1">
             <a:extLst>
               <a:ext uri="{FF2B5EF4-FFF2-40B4-BE49-F238E27FC236}">
-                <a16:creationId xmlns:a16="http://schemas.microsoft.com/office/drawing/2014/main" id="{9EAA7BDF-58E6-B876-2BF4-A72829EB0DE6}"/>
+                <a16:creationId xmlns:a16="http://schemas.microsoft.com/office/drawing/2014/main" id="{6BB8132E-4A6D-E701-E1D1-7B90B8F00FB8}"/>
               </a:ext>
             </a:extLst>
           </p:cNvPr>
@@ -2811,7 +2811,7 @@
           <p:cNvPr id="3" name="Marcador de texto 2">
             <a:extLst>
               <a:ext uri="{FF2B5EF4-FFF2-40B4-BE49-F238E27FC236}">
-                <a16:creationId xmlns:a16="http://schemas.microsoft.com/office/drawing/2014/main" id="{138C0B68-7040-A864-E0CA-EBDA9A05C9D3}"/>
+                <a16:creationId xmlns:a16="http://schemas.microsoft.com/office/drawing/2014/main" id="{E74F0ABB-71B6-2569-CA38-C2FF23CC2EE5}"/>
               </a:ext>
             </a:extLst>
           </p:cNvPr>
@@ -2878,7 +2878,7 @@
           <p:cNvPr id="4" name="Marcador de fecha 3">
             <a:extLst>
               <a:ext uri="{FF2B5EF4-FFF2-40B4-BE49-F238E27FC236}">
-                <a16:creationId xmlns:a16="http://schemas.microsoft.com/office/drawing/2014/main" id="{5362DBD6-8D60-910A-DEAA-1CFEC7176FAC}"/>
+                <a16:creationId xmlns:a16="http://schemas.microsoft.com/office/drawing/2014/main" id="{9D28B9E3-B669-98CD-0DFB-9444623D0492}"/>
               </a:ext>
             </a:extLst>
           </p:cNvPr>
@@ -2912,9 +2912,9 @@
             </a:lvl1pPr>
           </a:lstStyle>
           <a:p>
-            <a:fld id="{A2DFCF2F-AD49-4E39-AA7D-24C32A86171D}" type="datetimeFigureOut">
+            <a:fld id="{00E44E50-88F2-4BF5-98DE-3ABAC7B3EF02}" type="datetimeFigureOut">
               <a:rPr lang="es-ES" smtClean="0"/>
-              <a:t>30/03/2026</a:t>
+              <a:t>12/04/2026</a:t>
             </a:fld>
             <a:endParaRPr lang="es-ES"/>
           </a:p>
@@ -2925,7 +2925,7 @@
           <p:cNvPr id="5" name="Marcador de pie de página 4">
             <a:extLst>
               <a:ext uri="{FF2B5EF4-FFF2-40B4-BE49-F238E27FC236}">
-                <a16:creationId xmlns:a16="http://schemas.microsoft.com/office/drawing/2014/main" id="{11089994-052E-5D9B-2170-796E85C9F13B}"/>
+                <a16:creationId xmlns:a16="http://schemas.microsoft.com/office/drawing/2014/main" id="{B656AD14-05B4-92A6-FA8F-EADFB0CE5339}"/>
               </a:ext>
             </a:extLst>
           </p:cNvPr>
@@ -2968,7 +2968,7 @@
           <p:cNvPr id="6" name="Marcador de número de diapositiva 5">
             <a:extLst>
               <a:ext uri="{FF2B5EF4-FFF2-40B4-BE49-F238E27FC236}">
-                <a16:creationId xmlns:a16="http://schemas.microsoft.com/office/drawing/2014/main" id="{57970C50-C24F-0BBB-C6AF-9A3ACCC3D776}"/>
+                <a16:creationId xmlns:a16="http://schemas.microsoft.com/office/drawing/2014/main" id="{BB6C7FE4-CC40-DB1F-9F2A-08BF6AE7A2EA}"/>
               </a:ext>
             </a:extLst>
           </p:cNvPr>
@@ -3002,7 +3002,7 @@
             </a:lvl1pPr>
           </a:lstStyle>
           <a:p>
-            <a:fld id="{7D6E2D48-4366-4BA6-A433-D9E19997F8FC}" type="slidenum">
+            <a:fld id="{0E49D604-3501-452D-8397-28F2772CD1EC}" type="slidenum">
               <a:rPr lang="es-ES" smtClean="0"/>
               <a:t>‹Nº›</a:t>
             </a:fld>
@@ -3013,7 +3013,7 @@
     </p:spTree>
     <p:extLst>
       <p:ext uri="{BB962C8B-B14F-4D97-AF65-F5344CB8AC3E}">
-        <p14:creationId xmlns:p14="http://schemas.microsoft.com/office/powerpoint/2010/main" val="3717886468"/>
+        <p14:creationId xmlns:p14="http://schemas.microsoft.com/office/powerpoint/2010/main" val="3213372119"/>
       </p:ext>
     </p:extLst>
   </p:cSld>
@@ -3344,7 +3344,7 @@
           <p:cNvPr id="2" name="CuadroTexto 1">
             <a:extLst>
               <a:ext uri="{FF2B5EF4-FFF2-40B4-BE49-F238E27FC236}">
-                <a16:creationId xmlns:a16="http://schemas.microsoft.com/office/drawing/2014/main" id="{108AE622-C6C7-BF9E-00F7-3C0C7BA3679C}"/>
+                <a16:creationId xmlns:a16="http://schemas.microsoft.com/office/drawing/2014/main" id="{CA2AA10A-9FF8-A869-1536-A4A102CFE593}"/>
               </a:ext>
             </a:extLst>
           </p:cNvPr>
@@ -3384,7 +3384,7 @@
           <p:cNvPr id="3" name="CuadroTexto 2">
             <a:extLst>
               <a:ext uri="{FF2B5EF4-FFF2-40B4-BE49-F238E27FC236}">
-                <a16:creationId xmlns:a16="http://schemas.microsoft.com/office/drawing/2014/main" id="{EA6331B8-44D8-BEC8-EC76-8D23E8845539}"/>
+                <a16:creationId xmlns:a16="http://schemas.microsoft.com/office/drawing/2014/main" id="{370E24BB-B413-AD12-03CD-A2B0529F5A63}"/>
               </a:ext>
             </a:extLst>
           </p:cNvPr>
@@ -3424,7 +3424,7 @@
           <p:cNvPr id="4" name="CuadroTexto 3">
             <a:extLst>
               <a:ext uri="{FF2B5EF4-FFF2-40B4-BE49-F238E27FC236}">
-                <a16:creationId xmlns:a16="http://schemas.microsoft.com/office/drawing/2014/main" id="{EDBA894A-3C8E-045A-12EE-4425E40BFF0B}"/>
+                <a16:creationId xmlns:a16="http://schemas.microsoft.com/office/drawing/2014/main" id="{EC3766BD-9FEC-62CD-E93A-D2561B617E2E}"/>
               </a:ext>
             </a:extLst>
           </p:cNvPr>
@@ -3463,7 +3463,7 @@
     </p:spTree>
     <p:extLst>
       <p:ext uri="{BB962C8B-B14F-4D97-AF65-F5344CB8AC3E}">
-        <p14:creationId xmlns:p14="http://schemas.microsoft.com/office/powerpoint/2010/main" val="1021326975"/>
+        <p14:creationId xmlns:p14="http://schemas.microsoft.com/office/powerpoint/2010/main" val="3128052913"/>
       </p:ext>
     </p:extLst>
   </p:cSld>
@@ -3511,7 +3511,7 @@
           <p:cNvPr id="2" name="CuadroTexto 1">
             <a:extLst>
               <a:ext uri="{FF2B5EF4-FFF2-40B4-BE49-F238E27FC236}">
-                <a16:creationId xmlns:a16="http://schemas.microsoft.com/office/drawing/2014/main" id="{4931C6AF-4626-ECED-B926-D0C381D8414C}"/>
+                <a16:creationId xmlns:a16="http://schemas.microsoft.com/office/drawing/2014/main" id="{C9B83545-5FA1-DEB4-F62D-5C5BCC918CF3}"/>
               </a:ext>
             </a:extLst>
           </p:cNvPr>
@@ -3551,7 +3551,7 @@
           <p:cNvPr id="3" name="CuadroTexto 2">
             <a:extLst>
               <a:ext uri="{FF2B5EF4-FFF2-40B4-BE49-F238E27FC236}">
-                <a16:creationId xmlns:a16="http://schemas.microsoft.com/office/drawing/2014/main" id="{54490259-EFFF-81C3-704B-C12C82A3D655}"/>
+                <a16:creationId xmlns:a16="http://schemas.microsoft.com/office/drawing/2014/main" id="{CC15EB11-745B-C320-F296-69740CEEDDF1}"/>
               </a:ext>
             </a:extLst>
           </p:cNvPr>
@@ -3591,7 +3591,7 @@
           <p:cNvPr id="4" name="CuadroTexto 3">
             <a:extLst>
               <a:ext uri="{FF2B5EF4-FFF2-40B4-BE49-F238E27FC236}">
-                <a16:creationId xmlns:a16="http://schemas.microsoft.com/office/drawing/2014/main" id="{6BA5769D-3A3E-D467-7DF5-8174168E5823}"/>
+                <a16:creationId xmlns:a16="http://schemas.microsoft.com/office/drawing/2014/main" id="{369ACC22-4D17-E17C-8756-4E170051A109}"/>
               </a:ext>
             </a:extLst>
           </p:cNvPr>
@@ -3631,7 +3631,7 @@
           <p:cNvPr id="6" name="Imagen 5">
             <a:extLst>
               <a:ext uri="{FF2B5EF4-FFF2-40B4-BE49-F238E27FC236}">
-                <a16:creationId xmlns:a16="http://schemas.microsoft.com/office/drawing/2014/main" id="{3FE89B79-E91D-D9E0-29EF-66FFA9ABED33}"/>
+                <a16:creationId xmlns:a16="http://schemas.microsoft.com/office/drawing/2014/main" id="{CB4904FC-EBB6-13B0-8299-671BC1D9C70B}"/>
               </a:ext>
             </a:extLst>
           </p:cNvPr>
@@ -3665,7 +3665,7 @@
     </p:spTree>
     <p:extLst>
       <p:ext uri="{BB962C8B-B14F-4D97-AF65-F5344CB8AC3E}">
-        <p14:creationId xmlns:p14="http://schemas.microsoft.com/office/powerpoint/2010/main" val="3816807318"/>
+        <p14:creationId xmlns:p14="http://schemas.microsoft.com/office/powerpoint/2010/main" val="1907172357"/>
       </p:ext>
     </p:extLst>
   </p:cSld>
@@ -3713,7 +3713,7 @@
           <p:cNvPr id="2" name="CuadroTexto 1">
             <a:extLst>
               <a:ext uri="{FF2B5EF4-FFF2-40B4-BE49-F238E27FC236}">
-                <a16:creationId xmlns:a16="http://schemas.microsoft.com/office/drawing/2014/main" id="{57727FB2-ACA0-C5BB-1F34-4CE0ED4216F7}"/>
+                <a16:creationId xmlns:a16="http://schemas.microsoft.com/office/drawing/2014/main" id="{BDCF6160-78A1-EF37-1537-29B1FC013061}"/>
               </a:ext>
             </a:extLst>
           </p:cNvPr>
@@ -3753,7 +3753,7 @@
           <p:cNvPr id="3" name="CuadroTexto 2">
             <a:extLst>
               <a:ext uri="{FF2B5EF4-FFF2-40B4-BE49-F238E27FC236}">
-                <a16:creationId xmlns:a16="http://schemas.microsoft.com/office/drawing/2014/main" id="{9C3DDAD7-6332-0589-1979-F708AF0545BA}"/>
+                <a16:creationId xmlns:a16="http://schemas.microsoft.com/office/drawing/2014/main" id="{F6A21ACF-4F02-B5DE-D021-D0EF7A0C4A60}"/>
               </a:ext>
             </a:extLst>
           </p:cNvPr>
@@ -3793,7 +3793,7 @@
           <p:cNvPr id="4" name="CuadroTexto 3">
             <a:extLst>
               <a:ext uri="{FF2B5EF4-FFF2-40B4-BE49-F238E27FC236}">
-                <a16:creationId xmlns:a16="http://schemas.microsoft.com/office/drawing/2014/main" id="{D6EE7176-E6F2-17EC-D47E-13117FD79D5B}"/>
+                <a16:creationId xmlns:a16="http://schemas.microsoft.com/office/drawing/2014/main" id="{27AFB1FC-55D4-0209-6845-84B8092E5B0C}"/>
               </a:ext>
             </a:extLst>
           </p:cNvPr>
@@ -3831,7 +3831,7 @@
     </p:spTree>
     <p:extLst>
       <p:ext uri="{BB962C8B-B14F-4D97-AF65-F5344CB8AC3E}">
-        <p14:creationId xmlns:p14="http://schemas.microsoft.com/office/powerpoint/2010/main" val="568433181"/>
+        <p14:creationId xmlns:p14="http://schemas.microsoft.com/office/powerpoint/2010/main" val="1855538394"/>
       </p:ext>
     </p:extLst>
   </p:cSld>
@@ -3879,7 +3879,7 @@
           <p:cNvPr id="2" name="CuadroTexto 1">
             <a:extLst>
               <a:ext uri="{FF2B5EF4-FFF2-40B4-BE49-F238E27FC236}">
-                <a16:creationId xmlns:a16="http://schemas.microsoft.com/office/drawing/2014/main" id="{6C518490-B741-800C-B3AB-D4408A7FAAC2}"/>
+                <a16:creationId xmlns:a16="http://schemas.microsoft.com/office/drawing/2014/main" id="{F1D30C21-7680-28C5-23E9-212B305A7037}"/>
               </a:ext>
             </a:extLst>
           </p:cNvPr>
@@ -3919,7 +3919,7 @@
           <p:cNvPr id="3" name="CuadroTexto 2">
             <a:extLst>
               <a:ext uri="{FF2B5EF4-FFF2-40B4-BE49-F238E27FC236}">
-                <a16:creationId xmlns:a16="http://schemas.microsoft.com/office/drawing/2014/main" id="{5442F0B7-4635-B49B-061A-ECCDDA1D7FE3}"/>
+                <a16:creationId xmlns:a16="http://schemas.microsoft.com/office/drawing/2014/main" id="{E5F5873E-037F-5CF5-376F-C5547F741A3F}"/>
               </a:ext>
             </a:extLst>
           </p:cNvPr>
@@ -3959,7 +3959,7 @@
           <p:cNvPr id="4" name="CuadroTexto 3">
             <a:extLst>
               <a:ext uri="{FF2B5EF4-FFF2-40B4-BE49-F238E27FC236}">
-                <a16:creationId xmlns:a16="http://schemas.microsoft.com/office/drawing/2014/main" id="{20252252-F880-A97E-4DC2-B6B33BA08BB2}"/>
+                <a16:creationId xmlns:a16="http://schemas.microsoft.com/office/drawing/2014/main" id="{105C84BD-F31B-B77C-BDC9-2E31F32309AA}"/>
               </a:ext>
             </a:extLst>
           </p:cNvPr>
@@ -3999,7 +3999,7 @@
           <p:cNvPr id="6" name="Imagen 5">
             <a:extLst>
               <a:ext uri="{FF2B5EF4-FFF2-40B4-BE49-F238E27FC236}">
-                <a16:creationId xmlns:a16="http://schemas.microsoft.com/office/drawing/2014/main" id="{EE2CCDF4-1DE0-4D1C-7186-91C2A0F9DF9E}"/>
+                <a16:creationId xmlns:a16="http://schemas.microsoft.com/office/drawing/2014/main" id="{56BC244D-EECE-6923-E9DD-41C531731487}"/>
               </a:ext>
             </a:extLst>
           </p:cNvPr>
@@ -4033,7 +4033,7 @@
     </p:spTree>
     <p:extLst>
       <p:ext uri="{BB962C8B-B14F-4D97-AF65-F5344CB8AC3E}">
-        <p14:creationId xmlns:p14="http://schemas.microsoft.com/office/powerpoint/2010/main" val="1076655491"/>
+        <p14:creationId xmlns:p14="http://schemas.microsoft.com/office/powerpoint/2010/main" val="933253886"/>
       </p:ext>
     </p:extLst>
   </p:cSld>
@@ -4081,7 +4081,7 @@
           <p:cNvPr id="2" name="CuadroTexto 1">
             <a:extLst>
               <a:ext uri="{FF2B5EF4-FFF2-40B4-BE49-F238E27FC236}">
-                <a16:creationId xmlns:a16="http://schemas.microsoft.com/office/drawing/2014/main" id="{790B6AAD-9230-5855-5BEF-70C612C72043}"/>
+                <a16:creationId xmlns:a16="http://schemas.microsoft.com/office/drawing/2014/main" id="{F841F336-445B-4CC6-81F7-F8FCEDF6CD80}"/>
               </a:ext>
             </a:extLst>
           </p:cNvPr>
@@ -4121,7 +4121,7 @@
           <p:cNvPr id="3" name="CuadroTexto 2">
             <a:extLst>
               <a:ext uri="{FF2B5EF4-FFF2-40B4-BE49-F238E27FC236}">
-                <a16:creationId xmlns:a16="http://schemas.microsoft.com/office/drawing/2014/main" id="{C6D45154-1886-53F5-AC98-7D831C641C23}"/>
+                <a16:creationId xmlns:a16="http://schemas.microsoft.com/office/drawing/2014/main" id="{1B84EEE0-4E43-DC51-A216-118E313580C9}"/>
               </a:ext>
             </a:extLst>
           </p:cNvPr>
@@ -4161,7 +4161,7 @@
           <p:cNvPr id="4" name="CuadroTexto 3">
             <a:extLst>
               <a:ext uri="{FF2B5EF4-FFF2-40B4-BE49-F238E27FC236}">
-                <a16:creationId xmlns:a16="http://schemas.microsoft.com/office/drawing/2014/main" id="{6318325C-69AE-923F-3187-42423014E152}"/>
+                <a16:creationId xmlns:a16="http://schemas.microsoft.com/office/drawing/2014/main" id="{1B528FA9-6CD4-BD16-E1CF-939330684AEB}"/>
               </a:ext>
             </a:extLst>
           </p:cNvPr>
@@ -4200,7 +4200,7 @@
     </p:spTree>
     <p:extLst>
       <p:ext uri="{BB962C8B-B14F-4D97-AF65-F5344CB8AC3E}">
-        <p14:creationId xmlns:p14="http://schemas.microsoft.com/office/powerpoint/2010/main" val="1446036951"/>
+        <p14:creationId xmlns:p14="http://schemas.microsoft.com/office/powerpoint/2010/main" val="4216221831"/>
       </p:ext>
     </p:extLst>
   </p:cSld>
@@ -4248,7 +4248,7 @@
           <p:cNvPr id="2" name="CuadroTexto 1">
             <a:extLst>
               <a:ext uri="{FF2B5EF4-FFF2-40B4-BE49-F238E27FC236}">
-                <a16:creationId xmlns:a16="http://schemas.microsoft.com/office/drawing/2014/main" id="{D7735E47-2C04-EEEA-16F0-B18E0F9D9E0C}"/>
+                <a16:creationId xmlns:a16="http://schemas.microsoft.com/office/drawing/2014/main" id="{F4C0B7A3-97BE-CFFA-A9FC-EF1D10FD0BB0}"/>
               </a:ext>
             </a:extLst>
           </p:cNvPr>
@@ -4288,7 +4288,7 @@
           <p:cNvPr id="3" name="CuadroTexto 2">
             <a:extLst>
               <a:ext uri="{FF2B5EF4-FFF2-40B4-BE49-F238E27FC236}">
-                <a16:creationId xmlns:a16="http://schemas.microsoft.com/office/drawing/2014/main" id="{16A529CF-1091-3637-51C8-07BC7071F7CC}"/>
+                <a16:creationId xmlns:a16="http://schemas.microsoft.com/office/drawing/2014/main" id="{92C9259F-4082-13EA-4967-A68554644539}"/>
               </a:ext>
             </a:extLst>
           </p:cNvPr>
@@ -4328,7 +4328,7 @@
           <p:cNvPr id="4" name="CuadroTexto 3">
             <a:extLst>
               <a:ext uri="{FF2B5EF4-FFF2-40B4-BE49-F238E27FC236}">
-                <a16:creationId xmlns:a16="http://schemas.microsoft.com/office/drawing/2014/main" id="{9ED8482E-BFB1-584E-2C23-07E51265BBED}"/>
+                <a16:creationId xmlns:a16="http://schemas.microsoft.com/office/drawing/2014/main" id="{50578DF2-D8DD-0C95-23A8-8334A2C954A4}"/>
               </a:ext>
             </a:extLst>
           </p:cNvPr>
@@ -4359,7 +4359,7 @@
                 <a:latin typeface="Segoe UI" panose="020B0502040204020203" pitchFamily="34" charset="0"/>
               </a:rPr>
               <a:t>Aqui se ve un CSV real descargado desde la propia aplicacion.
-Lo estoy mostrando ya ordenado como hoja de calculo para que se aprecie mejor que la exportacion no es una demo falsa, sino un listado operativo que luego se puede abrir y trabajar fuera del sistema.</a:t>
+He anonimizado la muestra para la entrega, pero el archivo sigue saliendo del endpoint real y se puede abrir como hoja de calculo para trabajar fuera del sistema.</a:t>
             </a:r>
           </a:p>
         </p:txBody>
@@ -4369,7 +4369,7 @@
           <p:cNvPr id="5" name="Rectángulo 4">
             <a:extLst>
               <a:ext uri="{FF2B5EF4-FFF2-40B4-BE49-F238E27FC236}">
-                <a16:creationId xmlns:a16="http://schemas.microsoft.com/office/drawing/2014/main" id="{06B5144F-6551-A5B1-8764-8C48C7718331}"/>
+                <a16:creationId xmlns:a16="http://schemas.microsoft.com/office/drawing/2014/main" id="{66645E00-7233-ED4E-C36A-56619D165F52}"/>
               </a:ext>
             </a:extLst>
           </p:cNvPr>
@@ -4423,7 +4423,7 @@
           <p:cNvPr id="6" name="Tabla 5">
             <a:extLst>
               <a:ext uri="{FF2B5EF4-FFF2-40B4-BE49-F238E27FC236}">
-                <a16:creationId xmlns:a16="http://schemas.microsoft.com/office/drawing/2014/main" id="{6761A15E-049E-84F5-D76D-22EEBFCF21FB}"/>
+                <a16:creationId xmlns:a16="http://schemas.microsoft.com/office/drawing/2014/main" id="{4346EC65-E155-CE56-7883-6437D6E8710A}"/>
               </a:ext>
             </a:extLst>
           </p:cNvPr>
@@ -4433,7 +4433,7 @@
           <p:nvPr>
             <p:extLst>
               <p:ext uri="{D42A27DB-BD31-4B8C-83A1-F6EECF244321}">
-                <p14:modId xmlns:p14="http://schemas.microsoft.com/office/powerpoint/2010/main" val="507575090"/>
+                <p14:modId xmlns:p14="http://schemas.microsoft.com/office/powerpoint/2010/main" val="650577776"/>
               </p:ext>
             </p:extLst>
           </p:nvPr>
@@ -4452,42 +4452,42 @@
                 <a:gridCol w="533400">
                   <a:extLst>
                     <a:ext uri="{9D8B030D-6E8A-4147-A177-3AD203B41FA5}">
-                      <a16:colId xmlns:a16="http://schemas.microsoft.com/office/drawing/2014/main" val="1899090600"/>
+                      <a16:colId xmlns:a16="http://schemas.microsoft.com/office/drawing/2014/main" val="3117497450"/>
                     </a:ext>
                   </a:extLst>
                 </a:gridCol>
                 <a:gridCol w="2159000">
                   <a:extLst>
                     <a:ext uri="{9D8B030D-6E8A-4147-A177-3AD203B41FA5}">
-                      <a16:colId xmlns:a16="http://schemas.microsoft.com/office/drawing/2014/main" val="2285642083"/>
+                      <a16:colId xmlns:a16="http://schemas.microsoft.com/office/drawing/2014/main" val="561876594"/>
                     </a:ext>
                   </a:extLst>
                 </a:gridCol>
                 <a:gridCol w="2222500">
                   <a:extLst>
                     <a:ext uri="{9D8B030D-6E8A-4147-A177-3AD203B41FA5}">
-                      <a16:colId xmlns:a16="http://schemas.microsoft.com/office/drawing/2014/main" val="3829821688"/>
+                      <a16:colId xmlns:a16="http://schemas.microsoft.com/office/drawing/2014/main" val="1476651352"/>
                     </a:ext>
                   </a:extLst>
                 </a:gridCol>
                 <a:gridCol w="952500">
                   <a:extLst>
                     <a:ext uri="{9D8B030D-6E8A-4147-A177-3AD203B41FA5}">
-                      <a16:colId xmlns:a16="http://schemas.microsoft.com/office/drawing/2014/main" val="949040398"/>
+                      <a16:colId xmlns:a16="http://schemas.microsoft.com/office/drawing/2014/main" val="625704406"/>
                     </a:ext>
                   </a:extLst>
                 </a:gridCol>
                 <a:gridCol w="1117600">
                   <a:extLst>
                     <a:ext uri="{9D8B030D-6E8A-4147-A177-3AD203B41FA5}">
-                      <a16:colId xmlns:a16="http://schemas.microsoft.com/office/drawing/2014/main" val="305408760"/>
+                      <a16:colId xmlns:a16="http://schemas.microsoft.com/office/drawing/2014/main" val="3491998652"/>
                     </a:ext>
                   </a:extLst>
                 </a:gridCol>
                 <a:gridCol w="1117600">
                   <a:extLst>
                     <a:ext uri="{9D8B030D-6E8A-4147-A177-3AD203B41FA5}">
-                      <a16:colId xmlns:a16="http://schemas.microsoft.com/office/drawing/2014/main" val="2827011644"/>
+                      <a16:colId xmlns:a16="http://schemas.microsoft.com/office/drawing/2014/main" val="2608021489"/>
                     </a:ext>
                   </a:extLst>
                 </a:gridCol>
@@ -4627,7 +4627,7 @@
                 </a:tc>
                 <a:extLst>
                   <a:ext uri="{0D108BD9-81ED-4DB2-BD59-A6C34878D82A}">
-                    <a16:rowId xmlns:a16="http://schemas.microsoft.com/office/drawing/2014/main" val="2934261350"/>
+                    <a16:rowId xmlns:a16="http://schemas.microsoft.com/office/drawing/2014/main" val="2553043863"/>
                   </a:ext>
                 </a:extLst>
               </a:tr>
@@ -4644,7 +4644,7 @@
                           </a:solidFill>
                           <a:latin typeface="Calibri" panose="020F0502020204030204" pitchFamily="34" charset="0"/>
                         </a:rPr>
-                        <a:t>20</a:t>
+                        <a:t>21</a:t>
                       </a:r>
                     </a:p>
                   </a:txBody>
@@ -4666,7 +4666,7 @@
                           </a:solidFill>
                           <a:latin typeface="Calibri" panose="020F0502020204030204" pitchFamily="34" charset="0"/>
                         </a:rPr>
-                        <a:t>Empresa E2E 1774816472977</a:t>
+                        <a:t>Empresa demo 01</a:t>
                       </a:r>
                     </a:p>
                   </a:txBody>
@@ -4688,7 +4688,7 @@
                           </a:solidFill>
                           <a:latin typeface="Calibri" panose="020F0502020204030204" pitchFamily="34" charset="0"/>
                         </a:rPr>
-                        <a:t>e2e-1774816472977@example.com</a:t>
+                        <a:t>empresa01@demo.local</a:t>
                       </a:r>
                     </a:p>
                   </a:txBody>
@@ -4732,7 +4732,7 @@
                           </a:solidFill>
                           <a:latin typeface="Calibri" panose="020F0502020204030204" pitchFamily="34" charset="0"/>
                         </a:rPr>
-                        <a:t>2026-03-29 22:34:36</a:t>
+                        <a:t>2026-04-12 19:45:47</a:t>
                       </a:r>
                     </a:p>
                   </a:txBody>
@@ -4766,7 +4766,7 @@
                 </a:tc>
                 <a:extLst>
                   <a:ext uri="{0D108BD9-81ED-4DB2-BD59-A6C34878D82A}">
-                    <a16:rowId xmlns:a16="http://schemas.microsoft.com/office/drawing/2014/main" val="2697009421"/>
+                    <a16:rowId xmlns:a16="http://schemas.microsoft.com/office/drawing/2014/main" val="4075014290"/>
                   </a:ext>
                 </a:extLst>
               </a:tr>
@@ -4783,7 +4783,7 @@
                           </a:solidFill>
                           <a:latin typeface="Calibri" panose="020F0502020204030204" pitchFamily="34" charset="0"/>
                         </a:rPr>
-                        <a:t>19</a:t>
+                        <a:t>20</a:t>
                       </a:r>
                     </a:p>
                   </a:txBody>
@@ -4805,7 +4805,7 @@
                           </a:solidFill>
                           <a:latin typeface="Calibri" panose="020F0502020204030204" pitchFamily="34" charset="0"/>
                         </a:rPr>
-                        <a:t>Empresa E2E 1774816179992</a:t>
+                        <a:t>Empresa demo 02</a:t>
                       </a:r>
                     </a:p>
                   </a:txBody>
@@ -4827,7 +4827,7 @@
                           </a:solidFill>
                           <a:latin typeface="Calibri" panose="020F0502020204030204" pitchFamily="34" charset="0"/>
                         </a:rPr>
-                        <a:t>e2e-1774816179992@example.com</a:t>
+                        <a:t>empresa02@demo.local</a:t>
                       </a:r>
                     </a:p>
                   </a:txBody>
@@ -4871,7 +4871,7 @@
                           </a:solidFill>
                           <a:latin typeface="Calibri" panose="020F0502020204030204" pitchFamily="34" charset="0"/>
                         </a:rPr>
-                        <a:t>2026-03-29 22:29:42</a:t>
+                        <a:t>2026-03-29 22:34:36</a:t>
                       </a:r>
                     </a:p>
                   </a:txBody>
@@ -4905,7 +4905,7 @@
                 </a:tc>
                 <a:extLst>
                   <a:ext uri="{0D108BD9-81ED-4DB2-BD59-A6C34878D82A}">
-                    <a16:rowId xmlns:a16="http://schemas.microsoft.com/office/drawing/2014/main" val="712805022"/>
+                    <a16:rowId xmlns:a16="http://schemas.microsoft.com/office/drawing/2014/main" val="245165669"/>
                   </a:ext>
                 </a:extLst>
               </a:tr>
@@ -4922,7 +4922,7 @@
                           </a:solidFill>
                           <a:latin typeface="Calibri" panose="020F0502020204030204" pitchFamily="34" charset="0"/>
                         </a:rPr>
-                        <a:t>18</a:t>
+                        <a:t>19</a:t>
                       </a:r>
                     </a:p>
                   </a:txBody>
@@ -4944,7 +4944,7 @@
                           </a:solidFill>
                           <a:latin typeface="Calibri" panose="020F0502020204030204" pitchFamily="34" charset="0"/>
                         </a:rPr>
-                        <a:t>Empresa E2E 1774815640882</a:t>
+                        <a:t>Empresa demo 03</a:t>
                       </a:r>
                     </a:p>
                   </a:txBody>
@@ -4966,7 +4966,7 @@
                           </a:solidFill>
                           <a:latin typeface="Calibri" panose="020F0502020204030204" pitchFamily="34" charset="0"/>
                         </a:rPr>
-                        <a:t>e2e-1774815640882@example.com</a:t>
+                        <a:t>empresa03@demo.local</a:t>
                       </a:r>
                     </a:p>
                   </a:txBody>
@@ -5010,7 +5010,7 @@
                           </a:solidFill>
                           <a:latin typeface="Calibri" panose="020F0502020204030204" pitchFamily="34" charset="0"/>
                         </a:rPr>
-                        <a:t>2026-03-29 22:20:43</a:t>
+                        <a:t>2026-03-29 22:29:42</a:t>
                       </a:r>
                     </a:p>
                   </a:txBody>
@@ -5044,7 +5044,146 @@
                 </a:tc>
                 <a:extLst>
                   <a:ext uri="{0D108BD9-81ED-4DB2-BD59-A6C34878D82A}">
-                    <a16:rowId xmlns:a16="http://schemas.microsoft.com/office/drawing/2014/main" val="2052477408"/>
+                    <a16:rowId xmlns:a16="http://schemas.microsoft.com/office/drawing/2014/main" val="1205637903"/>
+                  </a:ext>
+                </a:extLst>
+              </a:tr>
+              <a:tr h="605971">
+                <a:tc>
+                  <a:txBody>
+                    <a:bodyPr/>
+                    <a:lstStyle/>
+                    <a:p>
+                      <a:r>
+                        <a:rPr lang="es-ES" sz="1000">
+                          <a:solidFill>
+                            <a:srgbClr val="37291F"/>
+                          </a:solidFill>
+                          <a:latin typeface="Calibri" panose="020F0502020204030204" pitchFamily="34" charset="0"/>
+                        </a:rPr>
+                        <a:t>18</a:t>
+                      </a:r>
+                    </a:p>
+                  </a:txBody>
+                  <a:tcPr marL="76200" marR="76200">
+                    <a:solidFill>
+                      <a:srgbClr val="F9F3ED"/>
+                    </a:solidFill>
+                  </a:tcPr>
+                </a:tc>
+                <a:tc>
+                  <a:txBody>
+                    <a:bodyPr/>
+                    <a:lstStyle/>
+                    <a:p>
+                      <a:r>
+                        <a:rPr lang="es-ES" sz="1000">
+                          <a:solidFill>
+                            <a:srgbClr val="37291F"/>
+                          </a:solidFill>
+                          <a:latin typeface="Calibri" panose="020F0502020204030204" pitchFamily="34" charset="0"/>
+                        </a:rPr>
+                        <a:t>Empresa demo 04</a:t>
+                      </a:r>
+                    </a:p>
+                  </a:txBody>
+                  <a:tcPr marL="76200" marR="76200">
+                    <a:solidFill>
+                      <a:srgbClr val="F9F3ED"/>
+                    </a:solidFill>
+                  </a:tcPr>
+                </a:tc>
+                <a:tc>
+                  <a:txBody>
+                    <a:bodyPr/>
+                    <a:lstStyle/>
+                    <a:p>
+                      <a:r>
+                        <a:rPr lang="es-ES" sz="1000">
+                          <a:solidFill>
+                            <a:srgbClr val="37291F"/>
+                          </a:solidFill>
+                          <a:latin typeface="Calibri" panose="020F0502020204030204" pitchFamily="34" charset="0"/>
+                        </a:rPr>
+                        <a:t>empresa04@demo.local</a:t>
+                      </a:r>
+                    </a:p>
+                  </a:txBody>
+                  <a:tcPr marL="76200" marR="76200">
+                    <a:solidFill>
+                      <a:srgbClr val="F9F3ED"/>
+                    </a:solidFill>
+                  </a:tcPr>
+                </a:tc>
+                <a:tc>
+                  <a:txBody>
+                    <a:bodyPr/>
+                    <a:lstStyle/>
+                    <a:p>
+                      <a:r>
+                        <a:rPr lang="es-ES" sz="1000">
+                          <a:solidFill>
+                            <a:srgbClr val="37291F"/>
+                          </a:solidFill>
+                          <a:latin typeface="Calibri" panose="020F0502020204030204" pitchFamily="34" charset="0"/>
+                        </a:rPr>
+                        <a:t>pendiente</a:t>
+                      </a:r>
+                    </a:p>
+                  </a:txBody>
+                  <a:tcPr marL="76200" marR="76200">
+                    <a:solidFill>
+                      <a:srgbClr val="F9F3ED"/>
+                    </a:solidFill>
+                  </a:tcPr>
+                </a:tc>
+                <a:tc>
+                  <a:txBody>
+                    <a:bodyPr/>
+                    <a:lstStyle/>
+                    <a:p>
+                      <a:r>
+                        <a:rPr lang="es-ES" sz="1000">
+                          <a:solidFill>
+                            <a:srgbClr val="37291F"/>
+                          </a:solidFill>
+                          <a:latin typeface="Calibri" panose="020F0502020204030204" pitchFamily="34" charset="0"/>
+                        </a:rPr>
+                        <a:t>2026-03-29 22:20:43</a:t>
+                      </a:r>
+                    </a:p>
+                  </a:txBody>
+                  <a:tcPr marL="76200" marR="76200">
+                    <a:solidFill>
+                      <a:srgbClr val="F9F3ED"/>
+                    </a:solidFill>
+                  </a:tcPr>
+                </a:tc>
+                <a:tc>
+                  <a:txBody>
+                    <a:bodyPr/>
+                    <a:lstStyle/>
+                    <a:p>
+                      <a:r>
+                        <a:rPr lang="es-ES" sz="1000">
+                          <a:solidFill>
+                            <a:srgbClr val="37291F"/>
+                          </a:solidFill>
+                          <a:latin typeface="Calibri" panose="020F0502020204030204" pitchFamily="34" charset="0"/>
+                        </a:rPr>
+                        <a:t>-</a:t>
+                      </a:r>
+                    </a:p>
+                  </a:txBody>
+                  <a:tcPr marL="76200" marR="76200">
+                    <a:solidFill>
+                      <a:srgbClr val="F9F3ED"/>
+                    </a:solidFill>
+                  </a:tcPr>
+                </a:tc>
+                <a:extLst>
+                  <a:ext uri="{0D108BD9-81ED-4DB2-BD59-A6C34878D82A}">
+                    <a16:rowId xmlns:a16="http://schemas.microsoft.com/office/drawing/2014/main" val="3548916322"/>
                   </a:ext>
                 </a:extLst>
               </a:tr>
@@ -5067,7 +5206,7 @@
                   </a:txBody>
                   <a:tcPr marL="76200" marR="76200">
                     <a:solidFill>
-                      <a:srgbClr val="F9F3ED"/>
+                      <a:srgbClr val="FDFAF7"/>
                     </a:solidFill>
                   </a:tcPr>
                 </a:tc>
@@ -5083,7 +5222,124 @@
                           </a:solidFill>
                           <a:latin typeface="Calibri" panose="020F0502020204030204" pitchFamily="34" charset="0"/>
                         </a:rPr>
-                        <a:t>Verificacion sync 203544</a:t>
+                        <a:t>Empresa demo 05</a:t>
+                      </a:r>
+                    </a:p>
+                  </a:txBody>
+                  <a:tcPr marL="76200" marR="76200">
+                    <a:solidFill>
+                      <a:srgbClr val="FDFAF7"/>
+                    </a:solidFill>
+                  </a:tcPr>
+                </a:tc>
+                <a:tc>
+                  <a:txBody>
+                    <a:bodyPr/>
+                    <a:lstStyle/>
+                    <a:p>
+                      <a:r>
+                        <a:rPr lang="es-ES" sz="1000">
+                          <a:solidFill>
+                            <a:srgbClr val="37291F"/>
+                          </a:solidFill>
+                          <a:latin typeface="Calibri" panose="020F0502020204030204" pitchFamily="34" charset="0"/>
+                        </a:rPr>
+                        <a:t>empresa05@demo.local</a:t>
+                      </a:r>
+                    </a:p>
+                  </a:txBody>
+                  <a:tcPr marL="76200" marR="76200">
+                    <a:solidFill>
+                      <a:srgbClr val="FDFAF7"/>
+                    </a:solidFill>
+                  </a:tcPr>
+                </a:tc>
+                <a:tc>
+                  <a:txBody>
+                    <a:bodyPr/>
+                    <a:lstStyle/>
+                    <a:p>
+                      <a:r>
+                        <a:rPr lang="es-ES" sz="1000">
+                          <a:solidFill>
+                            <a:srgbClr val="37291F"/>
+                          </a:solidFill>
+                          <a:latin typeface="Calibri" panose="020F0502020204030204" pitchFamily="34" charset="0"/>
+                        </a:rPr>
+                        <a:t>aprobada</a:t>
+                      </a:r>
+                    </a:p>
+                  </a:txBody>
+                  <a:tcPr marL="76200" marR="76200">
+                    <a:solidFill>
+                      <a:srgbClr val="FDFAF7"/>
+                    </a:solidFill>
+                  </a:tcPr>
+                </a:tc>
+                <a:tc>
+                  <a:txBody>
+                    <a:bodyPr/>
+                    <a:lstStyle/>
+                    <a:p>
+                      <a:r>
+                        <a:rPr lang="es-ES" sz="1000">
+                          <a:solidFill>
+                            <a:srgbClr val="37291F"/>
+                          </a:solidFill>
+                          <a:latin typeface="Calibri" panose="020F0502020204030204" pitchFamily="34" charset="0"/>
+                        </a:rPr>
+                        <a:t>2026-03-29 20:35:45</a:t>
+                      </a:r>
+                    </a:p>
+                  </a:txBody>
+                  <a:tcPr marL="76200" marR="76200">
+                    <a:solidFill>
+                      <a:srgbClr val="FDFAF7"/>
+                    </a:solidFill>
+                  </a:tcPr>
+                </a:tc>
+                <a:tc>
+                  <a:txBody>
+                    <a:bodyPr/>
+                    <a:lstStyle/>
+                    <a:p>
+                      <a:r>
+                        <a:rPr lang="es-ES" sz="1000">
+                          <a:solidFill>
+                            <a:srgbClr val="37291F"/>
+                          </a:solidFill>
+                          <a:latin typeface="Calibri" panose="020F0502020204030204" pitchFamily="34" charset="0"/>
+                        </a:rPr>
+                        <a:t>2026-03-29 20:44:36</a:t>
+                      </a:r>
+                    </a:p>
+                  </a:txBody>
+                  <a:tcPr marL="76200" marR="76200">
+                    <a:solidFill>
+                      <a:srgbClr val="FDFAF7"/>
+                    </a:solidFill>
+                  </a:tcPr>
+                </a:tc>
+                <a:extLst>
+                  <a:ext uri="{0D108BD9-81ED-4DB2-BD59-A6C34878D82A}">
+                    <a16:rowId xmlns:a16="http://schemas.microsoft.com/office/drawing/2014/main" val="3864025325"/>
+                  </a:ext>
+                </a:extLst>
+              </a:tr>
+              <a:tr h="605971">
+                <a:tc>
+                  <a:txBody>
+                    <a:bodyPr/>
+                    <a:lstStyle/>
+                    <a:p>
+                      <a:r>
+                        <a:rPr lang="es-ES" sz="1000">
+                          <a:solidFill>
+                            <a:srgbClr val="37291F"/>
+                          </a:solidFill>
+                          <a:latin typeface="Calibri" panose="020F0502020204030204" pitchFamily="34" charset="0"/>
+                        </a:rPr>
+                        <a:t>16</a:t>
                       </a:r>
                     </a:p>
                   </a:txBody>
@@ -5105,7 +5361,29 @@
                           </a:solidFill>
                           <a:latin typeface="Calibri" panose="020F0502020204030204" pitchFamily="34" charset="0"/>
                         </a:rPr>
-                        <a:t>lmendezgsd@gmail.com</a:t>
+                        <a:t>Empresa demo 06</a:t>
+                      </a:r>
+                    </a:p>
+                  </a:txBody>
+                  <a:tcPr marL="76200" marR="76200">
+                    <a:solidFill>
+                      <a:srgbClr val="F9F3ED"/>
+                    </a:solidFill>
+                  </a:tcPr>
+                </a:tc>
+                <a:tc>
+                  <a:txBody>
+                    <a:bodyPr/>
+                    <a:lstStyle/>
+                    <a:p>
+                      <a:r>
+                        <a:rPr lang="es-ES" sz="1000">
+                          <a:solidFill>
+                            <a:srgbClr val="37291F"/>
+                          </a:solidFill>
+                          <a:latin typeface="Calibri" panose="020F0502020204030204" pitchFamily="34" charset="0"/>
+                        </a:rPr>
+                        <a:t>empresa06@demo.local</a:t>
                       </a:r>
                     </a:p>
                   </a:txBody>
@@ -5149,7 +5427,7 @@
                           </a:solidFill>
                           <a:latin typeface="Calibri" panose="020F0502020204030204" pitchFamily="34" charset="0"/>
                         </a:rPr>
-                        <a:t>2026-03-29 20:35:45</a:t>
+                        <a:t>2026-03-29 20:32:45</a:t>
                       </a:r>
                     </a:p>
                   </a:txBody>
@@ -5171,7 +5449,7 @@
                           </a:solidFill>
                           <a:latin typeface="Calibri" panose="020F0502020204030204" pitchFamily="34" charset="0"/>
                         </a:rPr>
-                        <a:t>2026-03-29 20:44:36</a:t>
+                        <a:t>2026-03-29 20:47:16</a:t>
                       </a:r>
                     </a:p>
                   </a:txBody>
@@ -5183,285 +5461,7 @@
                 </a:tc>
                 <a:extLst>
                   <a:ext uri="{0D108BD9-81ED-4DB2-BD59-A6C34878D82A}">
-                    <a16:rowId xmlns:a16="http://schemas.microsoft.com/office/drawing/2014/main" val="4025805013"/>
-                  </a:ext>
-                </a:extLst>
-              </a:tr>
-              <a:tr h="605971">
-                <a:tc>
-                  <a:txBody>
-                    <a:bodyPr/>
-                    <a:lstStyle/>
-                    <a:p>
-                      <a:r>
-                        <a:rPr lang="es-ES" sz="1000">
-                          <a:solidFill>
-                            <a:srgbClr val="37291F"/>
-                          </a:solidFill>
-                          <a:latin typeface="Calibri" panose="020F0502020204030204" pitchFamily="34" charset="0"/>
-                        </a:rPr>
-                        <a:t>16</a:t>
-                      </a:r>
-                    </a:p>
-                  </a:txBody>
-                  <a:tcPr marL="76200" marR="76200">
-                    <a:solidFill>
-                      <a:srgbClr val="FDFAF7"/>
-                    </a:solidFill>
-                  </a:tcPr>
-                </a:tc>
-                <a:tc>
-                  <a:txBody>
-                    <a:bodyPr/>
-                    <a:lstStyle/>
-                    <a:p>
-                      <a:r>
-                        <a:rPr lang="es-ES" sz="1000">
-                          <a:solidFill>
-                            <a:srgbClr val="37291F"/>
-                          </a:solidFill>
-                          <a:latin typeface="Calibri" panose="020F0502020204030204" pitchFamily="34" charset="0"/>
-                        </a:rPr>
-                        <a:t>Prueba Portal Externo 203243</a:t>
-                      </a:r>
-                    </a:p>
-                  </a:txBody>
-                  <a:tcPr marL="76200" marR="76200">
-                    <a:solidFill>
-                      <a:srgbClr val="FDFAF7"/>
-                    </a:solidFill>
-                  </a:tcPr>
-                </a:tc>
-                <a:tc>
-                  <a:txBody>
-                    <a:bodyPr/>
-                    <a:lstStyle/>
-                    <a:p>
-                      <a:r>
-                        <a:rPr lang="es-ES" sz="1000">
-                          <a:solidFill>
-                            <a:srgbClr val="37291F"/>
-                          </a:solidFill>
-                          <a:latin typeface="Calibri" panose="020F0502020204030204" pitchFamily="34" charset="0"/>
-                        </a:rPr>
-                        <a:t>lmendezgsd@gmail.com</a:t>
-                      </a:r>
-                    </a:p>
-                  </a:txBody>
-                  <a:tcPr marL="76200" marR="76200">
-                    <a:solidFill>
-                      <a:srgbClr val="FDFAF7"/>
-                    </a:solidFill>
-                  </a:tcPr>
-                </a:tc>
-                <a:tc>
-                  <a:txBody>
-                    <a:bodyPr/>
-                    <a:lstStyle/>
-                    <a:p>
-                      <a:r>
-                        <a:rPr lang="es-ES" sz="1000">
-                          <a:solidFill>
-                            <a:srgbClr val="37291F"/>
-                          </a:solidFill>
-                          <a:latin typeface="Calibri" panose="020F0502020204030204" pitchFamily="34" charset="0"/>
-                        </a:rPr>
-                        <a:t>aprobada</a:t>
-                      </a:r>
-                    </a:p>
-                  </a:txBody>
-                  <a:tcPr marL="76200" marR="76200">
-                    <a:solidFill>
-                      <a:srgbClr val="FDFAF7"/>
-                    </a:solidFill>
-                  </a:tcPr>
-                </a:tc>
-                <a:tc>
-                  <a:txBody>
-                    <a:bodyPr/>
-                    <a:lstStyle/>
-                    <a:p>
-                      <a:r>
-                        <a:rPr lang="es-ES" sz="1000">
-                          <a:solidFill>
-                            <a:srgbClr val="37291F"/>
-                          </a:solidFill>
-                          <a:latin typeface="Calibri" panose="020F0502020204030204" pitchFamily="34" charset="0"/>
-                        </a:rPr>
-                        <a:t>2026-03-29 20:32:45</a:t>
-                      </a:r>
-                    </a:p>
-                  </a:txBody>
-                  <a:tcPr marL="76200" marR="76200">
-                    <a:solidFill>
-                      <a:srgbClr val="FDFAF7"/>
-                    </a:solidFill>
-                  </a:tcPr>
-                </a:tc>
-                <a:tc>
-                  <a:txBody>
-                    <a:bodyPr/>
-                    <a:lstStyle/>
-                    <a:p>
-                      <a:r>
-                        <a:rPr lang="es-ES" sz="1000">
-                          <a:solidFill>
-                            <a:srgbClr val="37291F"/>
-                          </a:solidFill>
-                          <a:latin typeface="Calibri" panose="020F0502020204030204" pitchFamily="34" charset="0"/>
-                        </a:rPr>
-                        <a:t>2026-03-29 20:47:16</a:t>
-                      </a:r>
-                    </a:p>
-                  </a:txBody>
-                  <a:tcPr marL="76200" marR="76200">
-                    <a:solidFill>
-                      <a:srgbClr val="FDFAF7"/>
-                    </a:solidFill>
-                  </a:tcPr>
-                </a:tc>
-                <a:extLst>
-                  <a:ext uri="{0D108BD9-81ED-4DB2-BD59-A6C34878D82A}">
-                    <a16:rowId xmlns:a16="http://schemas.microsoft.com/office/drawing/2014/main" val="1011198779"/>
-                  </a:ext>
-                </a:extLst>
-              </a:tr>
-              <a:tr h="605971">
-                <a:tc>
-                  <a:txBody>
-                    <a:bodyPr/>
-                    <a:lstStyle/>
-                    <a:p>
-                      <a:r>
-                        <a:rPr lang="es-ES" sz="1000">
-                          <a:solidFill>
-                            <a:srgbClr val="37291F"/>
-                          </a:solidFill>
-                          <a:latin typeface="Calibri" panose="020F0502020204030204" pitchFamily="34" charset="0"/>
-                        </a:rPr>
-                        <a:t>15</a:t>
-                      </a:r>
-                    </a:p>
-                  </a:txBody>
-                  <a:tcPr marL="76200" marR="76200">
-                    <a:solidFill>
-                      <a:srgbClr val="F9F3ED"/>
-                    </a:solidFill>
-                  </a:tcPr>
-                </a:tc>
-                <a:tc>
-                  <a:txBody>
-                    <a:bodyPr/>
-                    <a:lstStyle/>
-                    <a:p>
-                      <a:r>
-                        <a:rPr lang="es-ES" sz="1000">
-                          <a:solidFill>
-                            <a:srgbClr val="37291F"/>
-                          </a:solidFill>
-                          <a:latin typeface="Calibri" panose="020F0502020204030204" pitchFamily="34" charset="0"/>
-                        </a:rPr>
-                        <a:t>Prueba entrega Brevo</a:t>
-                      </a:r>
-                    </a:p>
-                  </a:txBody>
-                  <a:tcPr marL="76200" marR="76200">
-                    <a:solidFill>
-                      <a:srgbClr val="F9F3ED"/>
-                    </a:solidFill>
-                  </a:tcPr>
-                </a:tc>
-                <a:tc>
-                  <a:txBody>
-                    <a:bodyPr/>
-                    <a:lstStyle/>
-                    <a:p>
-                      <a:r>
-                        <a:rPr lang="es-ES" sz="1000">
-                          <a:solidFill>
-                            <a:srgbClr val="37291F"/>
-                          </a:solidFill>
-                          <a:latin typeface="Calibri" panose="020F0502020204030204" pitchFamily="34" charset="0"/>
-                        </a:rPr>
-                        <a:t>lmendezgsd@gmail.com</a:t>
-                      </a:r>
-                    </a:p>
-                  </a:txBody>
-                  <a:tcPr marL="76200" marR="76200">
-                    <a:solidFill>
-                      <a:srgbClr val="F9F3ED"/>
-                    </a:solidFill>
-                  </a:tcPr>
-                </a:tc>
-                <a:tc>
-                  <a:txBody>
-                    <a:bodyPr/>
-                    <a:lstStyle/>
-                    <a:p>
-                      <a:r>
-                        <a:rPr lang="es-ES" sz="1000">
-                          <a:solidFill>
-                            <a:srgbClr val="37291F"/>
-                          </a:solidFill>
-                          <a:latin typeface="Calibri" panose="020F0502020204030204" pitchFamily="34" charset="0"/>
-                        </a:rPr>
-                        <a:t>aprobada</a:t>
-                      </a:r>
-                    </a:p>
-                  </a:txBody>
-                  <a:tcPr marL="76200" marR="76200">
-                    <a:solidFill>
-                      <a:srgbClr val="F9F3ED"/>
-                    </a:solidFill>
-                  </a:tcPr>
-                </a:tc>
-                <a:tc>
-                  <a:txBody>
-                    <a:bodyPr/>
-                    <a:lstStyle/>
-                    <a:p>
-                      <a:r>
-                        <a:rPr lang="es-ES" sz="1000">
-                          <a:solidFill>
-                            <a:srgbClr val="37291F"/>
-                          </a:solidFill>
-                          <a:latin typeface="Calibri" panose="020F0502020204030204" pitchFamily="34" charset="0"/>
-                        </a:rPr>
-                        <a:t>2026-03-29 20:29:32</a:t>
-                      </a:r>
-                    </a:p>
-                  </a:txBody>
-                  <a:tcPr marL="76200" marR="76200">
-                    <a:solidFill>
-                      <a:srgbClr val="F9F3ED"/>
-                    </a:solidFill>
-                  </a:tcPr>
-                </a:tc>
-                <a:tc>
-                  <a:txBody>
-                    <a:bodyPr/>
-                    <a:lstStyle/>
-                    <a:p>
-                      <a:r>
-                        <a:rPr lang="es-ES" sz="1000">
-                          <a:solidFill>
-                            <a:srgbClr val="37291F"/>
-                          </a:solidFill>
-                          <a:latin typeface="Calibri" panose="020F0502020204030204" pitchFamily="34" charset="0"/>
-                        </a:rPr>
-                        <a:t>2026-03-29 20:47:18</a:t>
-                      </a:r>
-                    </a:p>
-                  </a:txBody>
-                  <a:tcPr marL="76200" marR="76200">
-                    <a:solidFill>
-                      <a:srgbClr val="F9F3ED"/>
-                    </a:solidFill>
-                  </a:tcPr>
-                </a:tc>
-                <a:extLst>
-                  <a:ext uri="{0D108BD9-81ED-4DB2-BD59-A6C34878D82A}">
-                    <a16:rowId xmlns:a16="http://schemas.microsoft.com/office/drawing/2014/main" val="940105995"/>
+                    <a16:rowId xmlns:a16="http://schemas.microsoft.com/office/drawing/2014/main" val="1218716612"/>
                   </a:ext>
                 </a:extLst>
               </a:tr>
@@ -5474,7 +5474,7 @@
           <p:cNvPr id="7" name="CuadroTexto 6">
             <a:extLst>
               <a:ext uri="{FF2B5EF4-FFF2-40B4-BE49-F238E27FC236}">
-                <a16:creationId xmlns:a16="http://schemas.microsoft.com/office/drawing/2014/main" id="{000B8BCB-636A-46F6-3F9E-87B3EBAF5251}"/>
+                <a16:creationId xmlns:a16="http://schemas.microsoft.com/office/drawing/2014/main" id="{2B725F00-84CE-ECC5-326E-DA69A9DC68D9}"/>
               </a:ext>
             </a:extLst>
           </p:cNvPr>
@@ -5505,7 +5505,7 @@
                 <a:latin typeface="Segoe UI" panose="020B0502040204020203" pitchFamily="34" charset="0"/>
               </a:rPr>
               <a:t>En este caso estoy ensenando la exportacion de solicitudes de empresa.
-El archivo sale del endpoint real del backend y tambien lo he dejado guardado en formato Excel para presentarlo de forma mas clara.</a:t>
+La muestra esta anonimizada para la entrega, pero el archivo sale del endpoint real del backend y tambien lo he dejado guardado en formato Excel para verlo mejor.</a:t>
             </a:r>
           </a:p>
         </p:txBody>
@@ -5513,7 +5513,7 @@
     </p:spTree>
     <p:extLst>
       <p:ext uri="{BB962C8B-B14F-4D97-AF65-F5344CB8AC3E}">
-        <p14:creationId xmlns:p14="http://schemas.microsoft.com/office/powerpoint/2010/main" val="354607200"/>
+        <p14:creationId xmlns:p14="http://schemas.microsoft.com/office/powerpoint/2010/main" val="3297203570"/>
       </p:ext>
     </p:extLst>
   </p:cSld>
@@ -5561,7 +5561,7 @@
           <p:cNvPr id="2" name="CuadroTexto 1">
             <a:extLst>
               <a:ext uri="{FF2B5EF4-FFF2-40B4-BE49-F238E27FC236}">
-                <a16:creationId xmlns:a16="http://schemas.microsoft.com/office/drawing/2014/main" id="{2898499E-6934-8E20-DC2E-D3EA144179EF}"/>
+                <a16:creationId xmlns:a16="http://schemas.microsoft.com/office/drawing/2014/main" id="{152C8FCB-B003-6817-DA0E-4D686C1819B6}"/>
               </a:ext>
             </a:extLst>
           </p:cNvPr>
@@ -5601,7 +5601,7 @@
           <p:cNvPr id="3" name="CuadroTexto 2">
             <a:extLst>
               <a:ext uri="{FF2B5EF4-FFF2-40B4-BE49-F238E27FC236}">
-                <a16:creationId xmlns:a16="http://schemas.microsoft.com/office/drawing/2014/main" id="{0FADAD9A-201B-358D-D7EA-7C8D671010F9}"/>
+                <a16:creationId xmlns:a16="http://schemas.microsoft.com/office/drawing/2014/main" id="{D2A59DF5-7569-8F9C-4708-0F3A53FD5F61}"/>
               </a:ext>
             </a:extLst>
           </p:cNvPr>
@@ -5641,7 +5641,7 @@
           <p:cNvPr id="4" name="CuadroTexto 3">
             <a:extLst>
               <a:ext uri="{FF2B5EF4-FFF2-40B4-BE49-F238E27FC236}">
-                <a16:creationId xmlns:a16="http://schemas.microsoft.com/office/drawing/2014/main" id="{67921C6F-9921-164A-5E9A-DF8ABDBF4BD8}"/>
+                <a16:creationId xmlns:a16="http://schemas.microsoft.com/office/drawing/2014/main" id="{AB8673C7-2674-BF1E-0C0B-D07E1DCC34CD}"/>
               </a:ext>
             </a:extLst>
           </p:cNvPr>
@@ -5681,7 +5681,7 @@
           <p:cNvPr id="6" name="Imagen 5">
             <a:extLst>
               <a:ext uri="{FF2B5EF4-FFF2-40B4-BE49-F238E27FC236}">
-                <a16:creationId xmlns:a16="http://schemas.microsoft.com/office/drawing/2014/main" id="{3AE0197D-E3D0-7A48-56B5-320A18D85E89}"/>
+                <a16:creationId xmlns:a16="http://schemas.microsoft.com/office/drawing/2014/main" id="{FAB54E5C-E3AB-F9D8-B420-7880D97CE827}"/>
               </a:ext>
             </a:extLst>
           </p:cNvPr>
@@ -5715,7 +5715,7 @@
     </p:spTree>
     <p:extLst>
       <p:ext uri="{BB962C8B-B14F-4D97-AF65-F5344CB8AC3E}">
-        <p14:creationId xmlns:p14="http://schemas.microsoft.com/office/powerpoint/2010/main" val="3503828121"/>
+        <p14:creationId xmlns:p14="http://schemas.microsoft.com/office/powerpoint/2010/main" val="1625253520"/>
       </p:ext>
     </p:extLst>
   </p:cSld>
@@ -5763,7 +5763,7 @@
           <p:cNvPr id="2" name="CuadroTexto 1">
             <a:extLst>
               <a:ext uri="{FF2B5EF4-FFF2-40B4-BE49-F238E27FC236}">
-                <a16:creationId xmlns:a16="http://schemas.microsoft.com/office/drawing/2014/main" id="{4A6ED40C-3329-58FD-D856-19B717477997}"/>
+                <a16:creationId xmlns:a16="http://schemas.microsoft.com/office/drawing/2014/main" id="{3598677D-C298-2EC4-C5C5-68B246CE171C}"/>
               </a:ext>
             </a:extLst>
           </p:cNvPr>
@@ -5803,7 +5803,7 @@
           <p:cNvPr id="3" name="CuadroTexto 2">
             <a:extLst>
               <a:ext uri="{FF2B5EF4-FFF2-40B4-BE49-F238E27FC236}">
-                <a16:creationId xmlns:a16="http://schemas.microsoft.com/office/drawing/2014/main" id="{FC4FD954-7B54-0993-F4BF-8AF0DDD46371}"/>
+                <a16:creationId xmlns:a16="http://schemas.microsoft.com/office/drawing/2014/main" id="{321D5841-2DAF-9A5B-E2C9-1963EB43E858}"/>
               </a:ext>
             </a:extLst>
           </p:cNvPr>
@@ -5843,7 +5843,7 @@
           <p:cNvPr id="4" name="CuadroTexto 3">
             <a:extLst>
               <a:ext uri="{FF2B5EF4-FFF2-40B4-BE49-F238E27FC236}">
-                <a16:creationId xmlns:a16="http://schemas.microsoft.com/office/drawing/2014/main" id="{E0E88463-5163-0C57-1830-D9372030A8D8}"/>
+                <a16:creationId xmlns:a16="http://schemas.microsoft.com/office/drawing/2014/main" id="{C4B2A70A-9D3C-0A19-1B55-ACAFD94855CF}"/>
               </a:ext>
             </a:extLst>
           </p:cNvPr>
@@ -5881,7 +5881,7 @@
     </p:spTree>
     <p:extLst>
       <p:ext uri="{BB962C8B-B14F-4D97-AF65-F5344CB8AC3E}">
-        <p14:creationId xmlns:p14="http://schemas.microsoft.com/office/powerpoint/2010/main" val="2522684866"/>
+        <p14:creationId xmlns:p14="http://schemas.microsoft.com/office/powerpoint/2010/main" val="4012916964"/>
       </p:ext>
     </p:extLst>
   </p:cSld>
@@ -5929,7 +5929,7 @@
           <p:cNvPr id="2" name="CuadroTexto 1">
             <a:extLst>
               <a:ext uri="{FF2B5EF4-FFF2-40B4-BE49-F238E27FC236}">
-                <a16:creationId xmlns:a16="http://schemas.microsoft.com/office/drawing/2014/main" id="{57A41502-C10A-6086-8110-DEB196D3A67C}"/>
+                <a16:creationId xmlns:a16="http://schemas.microsoft.com/office/drawing/2014/main" id="{A0E79776-55EE-834C-92F4-5A67ADB8929D}"/>
               </a:ext>
             </a:extLst>
           </p:cNvPr>
@@ -5969,7 +5969,7 @@
           <p:cNvPr id="3" name="CuadroTexto 2">
             <a:extLst>
               <a:ext uri="{FF2B5EF4-FFF2-40B4-BE49-F238E27FC236}">
-                <a16:creationId xmlns:a16="http://schemas.microsoft.com/office/drawing/2014/main" id="{082C1D70-8B78-8F99-C8B7-6825564EDB91}"/>
+                <a16:creationId xmlns:a16="http://schemas.microsoft.com/office/drawing/2014/main" id="{3CC05423-8B31-584D-9BCC-E1FBC0FED404}"/>
               </a:ext>
             </a:extLst>
           </p:cNvPr>
@@ -6009,7 +6009,7 @@
           <p:cNvPr id="4" name="CuadroTexto 3">
             <a:extLst>
               <a:ext uri="{FF2B5EF4-FFF2-40B4-BE49-F238E27FC236}">
-                <a16:creationId xmlns:a16="http://schemas.microsoft.com/office/drawing/2014/main" id="{29BC67A5-BC9E-E18E-2018-D2377AB79399}"/>
+                <a16:creationId xmlns:a16="http://schemas.microsoft.com/office/drawing/2014/main" id="{F884CFB2-DC34-E5FE-315A-5E10DBCD9966}"/>
               </a:ext>
             </a:extLst>
           </p:cNvPr>
@@ -6049,7 +6049,7 @@
           <p:cNvPr id="6" name="Imagen 5">
             <a:extLst>
               <a:ext uri="{FF2B5EF4-FFF2-40B4-BE49-F238E27FC236}">
-                <a16:creationId xmlns:a16="http://schemas.microsoft.com/office/drawing/2014/main" id="{148DEAC4-1623-8D19-CCEA-D626745E0B21}"/>
+                <a16:creationId xmlns:a16="http://schemas.microsoft.com/office/drawing/2014/main" id="{B871D841-93E7-E367-A81D-1525C2B11103}"/>
               </a:ext>
             </a:extLst>
           </p:cNvPr>
@@ -6083,7 +6083,7 @@
     </p:spTree>
     <p:extLst>
       <p:ext uri="{BB962C8B-B14F-4D97-AF65-F5344CB8AC3E}">
-        <p14:creationId xmlns:p14="http://schemas.microsoft.com/office/powerpoint/2010/main" val="3343584463"/>
+        <p14:creationId xmlns:p14="http://schemas.microsoft.com/office/powerpoint/2010/main" val="1752109718"/>
       </p:ext>
     </p:extLst>
   </p:cSld>
@@ -6131,7 +6131,7 @@
           <p:cNvPr id="2" name="CuadroTexto 1">
             <a:extLst>
               <a:ext uri="{FF2B5EF4-FFF2-40B4-BE49-F238E27FC236}">
-                <a16:creationId xmlns:a16="http://schemas.microsoft.com/office/drawing/2014/main" id="{93FF60A0-4AF8-59D0-683E-34D1B79A295C}"/>
+                <a16:creationId xmlns:a16="http://schemas.microsoft.com/office/drawing/2014/main" id="{8BEB3CD2-6638-7EF9-7277-CBD3EE3E20C7}"/>
               </a:ext>
             </a:extLst>
           </p:cNvPr>
@@ -6171,7 +6171,7 @@
           <p:cNvPr id="3" name="CuadroTexto 2">
             <a:extLst>
               <a:ext uri="{FF2B5EF4-FFF2-40B4-BE49-F238E27FC236}">
-                <a16:creationId xmlns:a16="http://schemas.microsoft.com/office/drawing/2014/main" id="{56601FF8-6C57-4FC5-D08A-04DBF1B17E87}"/>
+                <a16:creationId xmlns:a16="http://schemas.microsoft.com/office/drawing/2014/main" id="{B4CD027F-5577-08C7-D4E7-104A46DA9FB7}"/>
               </a:ext>
             </a:extLst>
           </p:cNvPr>
@@ -6211,7 +6211,7 @@
           <p:cNvPr id="4" name="CuadroTexto 3">
             <a:extLst>
               <a:ext uri="{FF2B5EF4-FFF2-40B4-BE49-F238E27FC236}">
-                <a16:creationId xmlns:a16="http://schemas.microsoft.com/office/drawing/2014/main" id="{FBC013F6-CF8D-38D1-B6F8-6A96BB5E19FB}"/>
+                <a16:creationId xmlns:a16="http://schemas.microsoft.com/office/drawing/2014/main" id="{309D942F-45B9-B310-3CDF-5A5F13E597B7}"/>
               </a:ext>
             </a:extLst>
           </p:cNvPr>
@@ -6249,7 +6249,7 @@
     </p:spTree>
     <p:extLst>
       <p:ext uri="{BB962C8B-B14F-4D97-AF65-F5344CB8AC3E}">
-        <p14:creationId xmlns:p14="http://schemas.microsoft.com/office/powerpoint/2010/main" val="2902704072"/>
+        <p14:creationId xmlns:p14="http://schemas.microsoft.com/office/powerpoint/2010/main" val="3720928202"/>
       </p:ext>
     </p:extLst>
   </p:cSld>
@@ -6297,7 +6297,7 @@
           <p:cNvPr id="2" name="CuadroTexto 1">
             <a:extLst>
               <a:ext uri="{FF2B5EF4-FFF2-40B4-BE49-F238E27FC236}">
-                <a16:creationId xmlns:a16="http://schemas.microsoft.com/office/drawing/2014/main" id="{E0AAC427-79F3-FA09-0674-6C04A1284D64}"/>
+                <a16:creationId xmlns:a16="http://schemas.microsoft.com/office/drawing/2014/main" id="{120002E4-DB17-5A6D-3FC8-AABB1BC64AE1}"/>
               </a:ext>
             </a:extLst>
           </p:cNvPr>
@@ -6337,7 +6337,7 @@
           <p:cNvPr id="3" name="CuadroTexto 2">
             <a:extLst>
               <a:ext uri="{FF2B5EF4-FFF2-40B4-BE49-F238E27FC236}">
-                <a16:creationId xmlns:a16="http://schemas.microsoft.com/office/drawing/2014/main" id="{4206FDB1-0EEA-707E-E876-CC126CF0244E}"/>
+                <a16:creationId xmlns:a16="http://schemas.microsoft.com/office/drawing/2014/main" id="{F279EBD3-A1E7-112D-8579-A60BA5EB244A}"/>
               </a:ext>
             </a:extLst>
           </p:cNvPr>
@@ -6377,7 +6377,7 @@
           <p:cNvPr id="4" name="CuadroTexto 3">
             <a:extLst>
               <a:ext uri="{FF2B5EF4-FFF2-40B4-BE49-F238E27FC236}">
-                <a16:creationId xmlns:a16="http://schemas.microsoft.com/office/drawing/2014/main" id="{1A7709BB-99A6-2FC1-CFD5-2B92C84D70C6}"/>
+                <a16:creationId xmlns:a16="http://schemas.microsoft.com/office/drawing/2014/main" id="{B083B309-558C-CD81-FE6E-73CC07F421F6}"/>
               </a:ext>
             </a:extLst>
           </p:cNvPr>
@@ -6417,7 +6417,7 @@
           <p:cNvPr id="6" name="Imagen 5">
             <a:extLst>
               <a:ext uri="{FF2B5EF4-FFF2-40B4-BE49-F238E27FC236}">
-                <a16:creationId xmlns:a16="http://schemas.microsoft.com/office/drawing/2014/main" id="{E7CC4375-DCA8-F0D2-B771-CF0499768E04}"/>
+                <a16:creationId xmlns:a16="http://schemas.microsoft.com/office/drawing/2014/main" id="{96C1E324-FC77-3FF6-609E-F2FDB1112806}"/>
               </a:ext>
             </a:extLst>
           </p:cNvPr>
@@ -6451,7 +6451,7 @@
     </p:spTree>
     <p:extLst>
       <p:ext uri="{BB962C8B-B14F-4D97-AF65-F5344CB8AC3E}">
-        <p14:creationId xmlns:p14="http://schemas.microsoft.com/office/powerpoint/2010/main" val="3963306873"/>
+        <p14:creationId xmlns:p14="http://schemas.microsoft.com/office/powerpoint/2010/main" val="1378376483"/>
       </p:ext>
     </p:extLst>
   </p:cSld>

</xml_diff>